<commit_message>
trying more augmentation changes
</commit_message>
<xml_diff>
--- a/meeting_updates/07.07.25.pptx
+++ b/meeting_updates/07.07.25.pptx
@@ -20,6 +20,8 @@
     <p:sldId id="286" r:id="rId14"/>
     <p:sldId id="287" r:id="rId15"/>
     <p:sldId id="284" r:id="rId16"/>
+    <p:sldId id="293" r:id="rId17"/>
+    <p:sldId id="294" r:id="rId18"/>
   </p:sldIdLst>
   <p:sldSz cx="12192000" cy="6858000"/>
   <p:notesSz cx="6858000" cy="9144000"/>
@@ -273,7 +275,7 @@
           <a:p>
             <a:fld id="{27AD023B-DDDA-446C-B96B-9ECDFF117D91}" type="datetimeFigureOut">
               <a:rPr lang="en-US" smtClean="0"/>
-              <a:t>7/7/2025</a:t>
+              <a:t>7/14/2025</a:t>
             </a:fld>
             <a:endParaRPr lang="en-US"/>
           </a:p>
@@ -471,7 +473,7 @@
           <a:p>
             <a:fld id="{27AD023B-DDDA-446C-B96B-9ECDFF117D91}" type="datetimeFigureOut">
               <a:rPr lang="en-US" smtClean="0"/>
-              <a:t>7/7/2025</a:t>
+              <a:t>7/14/2025</a:t>
             </a:fld>
             <a:endParaRPr lang="en-US"/>
           </a:p>
@@ -679,7 +681,7 @@
           <a:p>
             <a:fld id="{27AD023B-DDDA-446C-B96B-9ECDFF117D91}" type="datetimeFigureOut">
               <a:rPr lang="en-US" smtClean="0"/>
-              <a:t>7/7/2025</a:t>
+              <a:t>7/14/2025</a:t>
             </a:fld>
             <a:endParaRPr lang="en-US"/>
           </a:p>
@@ -877,7 +879,7 @@
           <a:p>
             <a:fld id="{27AD023B-DDDA-446C-B96B-9ECDFF117D91}" type="datetimeFigureOut">
               <a:rPr lang="en-US" smtClean="0"/>
-              <a:t>7/7/2025</a:t>
+              <a:t>7/14/2025</a:t>
             </a:fld>
             <a:endParaRPr lang="en-US"/>
           </a:p>
@@ -1152,7 +1154,7 @@
           <a:p>
             <a:fld id="{27AD023B-DDDA-446C-B96B-9ECDFF117D91}" type="datetimeFigureOut">
               <a:rPr lang="en-US" smtClean="0"/>
-              <a:t>7/7/2025</a:t>
+              <a:t>7/14/2025</a:t>
             </a:fld>
             <a:endParaRPr lang="en-US"/>
           </a:p>
@@ -1417,7 +1419,7 @@
           <a:p>
             <a:fld id="{27AD023B-DDDA-446C-B96B-9ECDFF117D91}" type="datetimeFigureOut">
               <a:rPr lang="en-US" smtClean="0"/>
-              <a:t>7/7/2025</a:t>
+              <a:t>7/14/2025</a:t>
             </a:fld>
             <a:endParaRPr lang="en-US"/>
           </a:p>
@@ -1829,7 +1831,7 @@
           <a:p>
             <a:fld id="{27AD023B-DDDA-446C-B96B-9ECDFF117D91}" type="datetimeFigureOut">
               <a:rPr lang="en-US" smtClean="0"/>
-              <a:t>7/7/2025</a:t>
+              <a:t>7/14/2025</a:t>
             </a:fld>
             <a:endParaRPr lang="en-US"/>
           </a:p>
@@ -1970,7 +1972,7 @@
           <a:p>
             <a:fld id="{27AD023B-DDDA-446C-B96B-9ECDFF117D91}" type="datetimeFigureOut">
               <a:rPr lang="en-US" smtClean="0"/>
-              <a:t>7/7/2025</a:t>
+              <a:t>7/14/2025</a:t>
             </a:fld>
             <a:endParaRPr lang="en-US"/>
           </a:p>
@@ -2083,7 +2085,7 @@
           <a:p>
             <a:fld id="{27AD023B-DDDA-446C-B96B-9ECDFF117D91}" type="datetimeFigureOut">
               <a:rPr lang="en-US" smtClean="0"/>
-              <a:t>7/7/2025</a:t>
+              <a:t>7/14/2025</a:t>
             </a:fld>
             <a:endParaRPr lang="en-US"/>
           </a:p>
@@ -2394,7 +2396,7 @@
           <a:p>
             <a:fld id="{27AD023B-DDDA-446C-B96B-9ECDFF117D91}" type="datetimeFigureOut">
               <a:rPr lang="en-US" smtClean="0"/>
-              <a:t>7/7/2025</a:t>
+              <a:t>7/14/2025</a:t>
             </a:fld>
             <a:endParaRPr lang="en-US"/>
           </a:p>
@@ -2682,7 +2684,7 @@
           <a:p>
             <a:fld id="{27AD023B-DDDA-446C-B96B-9ECDFF117D91}" type="datetimeFigureOut">
               <a:rPr lang="en-US" smtClean="0"/>
-              <a:t>7/7/2025</a:t>
+              <a:t>7/14/2025</a:t>
             </a:fld>
             <a:endParaRPr lang="en-US"/>
           </a:p>
@@ -2923,7 +2925,7 @@
           <a:p>
             <a:fld id="{27AD023B-DDDA-446C-B96B-9ECDFF117D91}" type="datetimeFigureOut">
               <a:rPr lang="en-US" smtClean="0"/>
-              <a:t>7/7/2025</a:t>
+              <a:t>7/14/2025</a:t>
             </a:fld>
             <a:endParaRPr lang="en-US"/>
           </a:p>
@@ -11099,6 +11101,4020 @@
     <p:extLst>
       <p:ext uri="{BB962C8B-B14F-4D97-AF65-F5344CB8AC3E}">
         <p14:creationId xmlns:p14="http://schemas.microsoft.com/office/powerpoint/2010/main" val="1183768397"/>
+      </p:ext>
+    </p:extLst>
+  </p:cSld>
+  <p:clrMapOvr>
+    <a:masterClrMapping/>
+  </p:clrMapOvr>
+</p:sld>
+</file>
+
+<file path=ppt/slides/slide16.xml><?xml version="1.0" encoding="utf-8"?>
+<p:sld xmlns:a="http://schemas.openxmlformats.org/drawingml/2006/main" xmlns:r="http://schemas.openxmlformats.org/officeDocument/2006/relationships" xmlns:p="http://schemas.openxmlformats.org/presentationml/2006/main">
+  <p:cSld>
+    <p:spTree>
+      <p:nvGrpSpPr>
+        <p:cNvPr id="1" name="">
+          <a:extLst>
+            <a:ext uri="{FF2B5EF4-FFF2-40B4-BE49-F238E27FC236}">
+              <a16:creationId xmlns:a16="http://schemas.microsoft.com/office/drawing/2014/main" id="{EE3E914D-ABBF-9279-CC55-BDCBD9EECEA6}"/>
+            </a:ext>
+          </a:extLst>
+        </p:cNvPr>
+        <p:cNvGrpSpPr/>
+        <p:nvPr/>
+      </p:nvGrpSpPr>
+      <p:grpSpPr>
+        <a:xfrm>
+          <a:off x="0" y="0"/>
+          <a:ext cx="0" cy="0"/>
+          <a:chOff x="0" y="0"/>
+          <a:chExt cx="0" cy="0"/>
+        </a:xfrm>
+      </p:grpSpPr>
+      <p:cxnSp>
+        <p:nvCxnSpPr>
+          <p:cNvPr id="45" name="Straight Arrow Connector 44">
+            <a:extLst>
+              <a:ext uri="{FF2B5EF4-FFF2-40B4-BE49-F238E27FC236}">
+                <a16:creationId xmlns:a16="http://schemas.microsoft.com/office/drawing/2014/main" id="{9D107761-021B-A81D-8BC2-BE5836385787}"/>
+              </a:ext>
+            </a:extLst>
+          </p:cNvPr>
+          <p:cNvCxnSpPr>
+            <a:cxnSpLocks/>
+            <a:stCxn id="23" idx="4"/>
+          </p:cNvCxnSpPr>
+          <p:nvPr/>
+        </p:nvCxnSpPr>
+        <p:spPr>
+          <a:xfrm flipV="1">
+            <a:off x="10860022" y="3114495"/>
+            <a:ext cx="913636" cy="1353312"/>
+          </a:xfrm>
+          <a:prstGeom prst="straightConnector1">
+            <a:avLst/>
+          </a:prstGeom>
+          <a:ln>
+            <a:tailEnd type="triangle"/>
+          </a:ln>
+        </p:spPr>
+        <p:style>
+          <a:lnRef idx="2">
+            <a:schemeClr val="accent1"/>
+          </a:lnRef>
+          <a:fillRef idx="0">
+            <a:schemeClr val="accent1"/>
+          </a:fillRef>
+          <a:effectRef idx="1">
+            <a:schemeClr val="accent1"/>
+          </a:effectRef>
+          <a:fontRef idx="minor">
+            <a:schemeClr val="tx1"/>
+          </a:fontRef>
+        </p:style>
+      </p:cxnSp>
+      <p:sp>
+        <p:nvSpPr>
+          <p:cNvPr id="49" name="Flowchart: Manual Operation 48">
+            <a:extLst>
+              <a:ext uri="{FF2B5EF4-FFF2-40B4-BE49-F238E27FC236}">
+                <a16:creationId xmlns:a16="http://schemas.microsoft.com/office/drawing/2014/main" id="{34447C4C-9482-564B-A4C4-802D6A87FA25}"/>
+              </a:ext>
+            </a:extLst>
+          </p:cNvPr>
+          <p:cNvSpPr/>
+          <p:nvPr/>
+        </p:nvSpPr>
+        <p:spPr>
+          <a:xfrm rot="16200000">
+            <a:off x="7331960" y="3398895"/>
+            <a:ext cx="1234440" cy="1536192"/>
+          </a:xfrm>
+          <a:prstGeom prst="flowChartManualOperation">
+            <a:avLst/>
+          </a:prstGeom>
+        </p:spPr>
+        <p:style>
+          <a:lnRef idx="2">
+            <a:schemeClr val="accent1">
+              <a:shade val="15000"/>
+            </a:schemeClr>
+          </a:lnRef>
+          <a:fillRef idx="1">
+            <a:schemeClr val="accent1"/>
+          </a:fillRef>
+          <a:effectRef idx="0">
+            <a:schemeClr val="accent1"/>
+          </a:effectRef>
+          <a:fontRef idx="minor">
+            <a:schemeClr val="lt1"/>
+          </a:fontRef>
+        </p:style>
+        <p:txBody>
+          <a:bodyPr rtlCol="0" anchor="ctr"/>
+          <a:lstStyle/>
+          <a:p>
+            <a:pPr algn="ctr"/>
+            <a:endParaRPr lang="en-US" dirty="0"/>
+          </a:p>
+        </p:txBody>
+      </p:sp>
+      <p:sp>
+        <p:nvSpPr>
+          <p:cNvPr id="2" name="TextBox 1">
+            <a:extLst>
+              <a:ext uri="{FF2B5EF4-FFF2-40B4-BE49-F238E27FC236}">
+                <a16:creationId xmlns:a16="http://schemas.microsoft.com/office/drawing/2014/main" id="{3F7CEE61-4AC5-7602-7220-8ED52F3CC008}"/>
+              </a:ext>
+            </a:extLst>
+          </p:cNvPr>
+          <p:cNvSpPr txBox="1"/>
+          <p:nvPr/>
+        </p:nvSpPr>
+        <p:spPr>
+          <a:xfrm>
+            <a:off x="797050" y="714205"/>
+            <a:ext cx="2688336" cy="369332"/>
+          </a:xfrm>
+          <a:prstGeom prst="rect">
+            <a:avLst/>
+          </a:prstGeom>
+          <a:noFill/>
+        </p:spPr>
+        <p:txBody>
+          <a:bodyPr wrap="square" rtlCol="0">
+            <a:spAutoFit/>
+          </a:bodyPr>
+          <a:lstStyle/>
+          <a:p>
+            <a:r>
+              <a:rPr lang="en-US" dirty="0"/>
+              <a:t>Experiment 4.3: </a:t>
+            </a:r>
+          </a:p>
+        </p:txBody>
+      </p:sp>
+      <p:sp>
+        <p:nvSpPr>
+          <p:cNvPr id="3" name="TextBox 2">
+            <a:extLst>
+              <a:ext uri="{FF2B5EF4-FFF2-40B4-BE49-F238E27FC236}">
+                <a16:creationId xmlns:a16="http://schemas.microsoft.com/office/drawing/2014/main" id="{01788985-9829-FC77-7689-C5D13F891C19}"/>
+              </a:ext>
+            </a:extLst>
+          </p:cNvPr>
+          <p:cNvSpPr txBox="1"/>
+          <p:nvPr/>
+        </p:nvSpPr>
+        <p:spPr>
+          <a:xfrm>
+            <a:off x="858201" y="914425"/>
+            <a:ext cx="4502277" cy="2862322"/>
+          </a:xfrm>
+          <a:prstGeom prst="rect">
+            <a:avLst/>
+          </a:prstGeom>
+          <a:noFill/>
+        </p:spPr>
+        <p:txBody>
+          <a:bodyPr wrap="square" rtlCol="0">
+            <a:spAutoFit/>
+          </a:bodyPr>
+          <a:lstStyle/>
+          <a:p>
+            <a:endParaRPr lang="en-US" dirty="0"/>
+          </a:p>
+          <a:p>
+            <a:pPr marL="285750" indent="-285750">
+              <a:buFont typeface="Arial" panose="020B0604020202020204" pitchFamily="34" charset="0"/>
+              <a:buChar char="•"/>
+            </a:pPr>
+            <a:r>
+              <a:rPr lang="en-US" dirty="0"/>
+              <a:t>Binary Classification Setup </a:t>
+            </a:r>
+          </a:p>
+          <a:p>
+            <a:pPr marL="285750" indent="-285750">
+              <a:buFont typeface="Arial" panose="020B0604020202020204" pitchFamily="34" charset="0"/>
+              <a:buChar char="•"/>
+            </a:pPr>
+            <a:r>
+              <a:rPr lang="en-US" dirty="0"/>
+              <a:t>Classification Based on US Image Only</a:t>
+            </a:r>
+          </a:p>
+          <a:p>
+            <a:pPr marL="285750" indent="-285750">
+              <a:buFont typeface="Arial" panose="020B0604020202020204" pitchFamily="34" charset="0"/>
+              <a:buChar char="•"/>
+            </a:pPr>
+            <a:r>
+              <a:rPr lang="en-US" dirty="0"/>
+              <a:t>4 separate encoder with different types of US input </a:t>
+            </a:r>
+          </a:p>
+          <a:p>
+            <a:pPr marL="285750" indent="-285750">
+              <a:buFont typeface="Arial" panose="020B0604020202020204" pitchFamily="34" charset="0"/>
+              <a:buChar char="•"/>
+            </a:pPr>
+            <a:r>
+              <a:rPr lang="en-US" dirty="0"/>
+              <a:t>Linear layer weighted score</a:t>
+            </a:r>
+          </a:p>
+          <a:p>
+            <a:pPr marL="285750" indent="-285750">
+              <a:buFont typeface="Arial" panose="020B0604020202020204" pitchFamily="34" charset="0"/>
+              <a:buChar char="•"/>
+            </a:pPr>
+            <a:r>
+              <a:rPr lang="en-US" dirty="0" err="1"/>
+              <a:t>Asymmetrics</a:t>
+            </a:r>
+            <a:r>
+              <a:rPr lang="en-US" dirty="0"/>
+              <a:t> Loss + Focal Loss</a:t>
+            </a:r>
+          </a:p>
+          <a:p>
+            <a:pPr marL="285750" indent="-285750">
+              <a:buFont typeface="Arial" panose="020B0604020202020204" pitchFamily="34" charset="0"/>
+              <a:buChar char="•"/>
+            </a:pPr>
+            <a:r>
+              <a:rPr lang="en-US" dirty="0" err="1"/>
+              <a:t>Testset</a:t>
+            </a:r>
+            <a:r>
+              <a:rPr lang="en-US" dirty="0"/>
+              <a:t> on 4 to 20 Patient IDs:</a:t>
+            </a:r>
+          </a:p>
+          <a:p>
+            <a:pPr marL="285750" indent="-285750">
+              <a:buFont typeface="Arial" panose="020B0604020202020204" pitchFamily="34" charset="0"/>
+              <a:buChar char="•"/>
+            </a:pPr>
+            <a:endParaRPr lang="en-US" dirty="0"/>
+          </a:p>
+          <a:p>
+            <a:pPr marL="285750" indent="-285750">
+              <a:buFont typeface="Arial" panose="020B0604020202020204" pitchFamily="34" charset="0"/>
+              <a:buChar char="•"/>
+            </a:pPr>
+            <a:endParaRPr lang="en-US" dirty="0"/>
+          </a:p>
+        </p:txBody>
+      </p:sp>
+      <p:sp>
+        <p:nvSpPr>
+          <p:cNvPr id="4" name="Flowchart: Manual Operation 3">
+            <a:extLst>
+              <a:ext uri="{FF2B5EF4-FFF2-40B4-BE49-F238E27FC236}">
+                <a16:creationId xmlns:a16="http://schemas.microsoft.com/office/drawing/2014/main" id="{533745B2-152A-2623-EBFF-03916909D57F}"/>
+              </a:ext>
+            </a:extLst>
+          </p:cNvPr>
+          <p:cNvSpPr/>
+          <p:nvPr/>
+        </p:nvSpPr>
+        <p:spPr>
+          <a:xfrm rot="16200000">
+            <a:off x="7339582" y="-37539"/>
+            <a:ext cx="1234440" cy="1536192"/>
+          </a:xfrm>
+          <a:prstGeom prst="flowChartManualOperation">
+            <a:avLst/>
+          </a:prstGeom>
+        </p:spPr>
+        <p:style>
+          <a:lnRef idx="2">
+            <a:schemeClr val="accent1">
+              <a:shade val="15000"/>
+            </a:schemeClr>
+          </a:lnRef>
+          <a:fillRef idx="1">
+            <a:schemeClr val="accent1"/>
+          </a:fillRef>
+          <a:effectRef idx="0">
+            <a:schemeClr val="accent1"/>
+          </a:effectRef>
+          <a:fontRef idx="minor">
+            <a:schemeClr val="lt1"/>
+          </a:fontRef>
+        </p:style>
+        <p:txBody>
+          <a:bodyPr rtlCol="0" anchor="ctr"/>
+          <a:lstStyle/>
+          <a:p>
+            <a:pPr algn="ctr"/>
+            <a:endParaRPr lang="en-US" dirty="0"/>
+          </a:p>
+        </p:txBody>
+      </p:sp>
+      <p:sp>
+        <p:nvSpPr>
+          <p:cNvPr id="5" name="Flowchart: Manual Operation 4">
+            <a:extLst>
+              <a:ext uri="{FF2B5EF4-FFF2-40B4-BE49-F238E27FC236}">
+                <a16:creationId xmlns:a16="http://schemas.microsoft.com/office/drawing/2014/main" id="{18EBFFAB-AD70-7B92-8470-6749FA26122B}"/>
+              </a:ext>
+            </a:extLst>
+          </p:cNvPr>
+          <p:cNvSpPr/>
+          <p:nvPr/>
+        </p:nvSpPr>
+        <p:spPr>
+          <a:xfrm rot="16200000">
+            <a:off x="7339582" y="1777545"/>
+            <a:ext cx="1234440" cy="1536192"/>
+          </a:xfrm>
+          <a:prstGeom prst="flowChartManualOperation">
+            <a:avLst/>
+          </a:prstGeom>
+        </p:spPr>
+        <p:style>
+          <a:lnRef idx="2">
+            <a:schemeClr val="accent1">
+              <a:shade val="15000"/>
+            </a:schemeClr>
+          </a:lnRef>
+          <a:fillRef idx="1">
+            <a:schemeClr val="accent1"/>
+          </a:fillRef>
+          <a:effectRef idx="0">
+            <a:schemeClr val="accent1"/>
+          </a:effectRef>
+          <a:fontRef idx="minor">
+            <a:schemeClr val="lt1"/>
+          </a:fontRef>
+        </p:style>
+        <p:txBody>
+          <a:bodyPr rtlCol="0" anchor="ctr"/>
+          <a:lstStyle/>
+          <a:p>
+            <a:pPr algn="ctr"/>
+            <a:endParaRPr lang="en-US"/>
+          </a:p>
+        </p:txBody>
+      </p:sp>
+      <p:sp>
+        <p:nvSpPr>
+          <p:cNvPr id="6" name="Rectangle 5">
+            <a:extLst>
+              <a:ext uri="{FF2B5EF4-FFF2-40B4-BE49-F238E27FC236}">
+                <a16:creationId xmlns:a16="http://schemas.microsoft.com/office/drawing/2014/main" id="{DC688524-3B99-B85D-C24A-523F625C6A50}"/>
+              </a:ext>
+            </a:extLst>
+          </p:cNvPr>
+          <p:cNvSpPr/>
+          <p:nvPr/>
+        </p:nvSpPr>
+        <p:spPr>
+          <a:xfrm>
+            <a:off x="9214102" y="323649"/>
+            <a:ext cx="612648" cy="813816"/>
+          </a:xfrm>
+          <a:prstGeom prst="rect">
+            <a:avLst/>
+          </a:prstGeom>
+        </p:spPr>
+        <p:style>
+          <a:lnRef idx="2">
+            <a:schemeClr val="accent1">
+              <a:shade val="15000"/>
+            </a:schemeClr>
+          </a:lnRef>
+          <a:fillRef idx="1">
+            <a:schemeClr val="accent1"/>
+          </a:fillRef>
+          <a:effectRef idx="0">
+            <a:schemeClr val="accent1"/>
+          </a:effectRef>
+          <a:fontRef idx="minor">
+            <a:schemeClr val="lt1"/>
+          </a:fontRef>
+        </p:style>
+        <p:txBody>
+          <a:bodyPr rtlCol="0" anchor="ctr"/>
+          <a:lstStyle/>
+          <a:p>
+            <a:pPr algn="ctr"/>
+            <a:r>
+              <a:rPr lang="en-US" sz="1000" dirty="0"/>
+              <a:t>FC Layer</a:t>
+            </a:r>
+          </a:p>
+        </p:txBody>
+      </p:sp>
+      <p:sp>
+        <p:nvSpPr>
+          <p:cNvPr id="7" name="Rectangle 6">
+            <a:extLst>
+              <a:ext uri="{FF2B5EF4-FFF2-40B4-BE49-F238E27FC236}">
+                <a16:creationId xmlns:a16="http://schemas.microsoft.com/office/drawing/2014/main" id="{9107BA0F-9B13-9A86-9690-F7B8D4AB8963}"/>
+              </a:ext>
+            </a:extLst>
+          </p:cNvPr>
+          <p:cNvSpPr/>
+          <p:nvPr/>
+        </p:nvSpPr>
+        <p:spPr>
+          <a:xfrm>
+            <a:off x="9214102" y="2138733"/>
+            <a:ext cx="612648" cy="813816"/>
+          </a:xfrm>
+          <a:prstGeom prst="rect">
+            <a:avLst/>
+          </a:prstGeom>
+        </p:spPr>
+        <p:style>
+          <a:lnRef idx="2">
+            <a:schemeClr val="accent1">
+              <a:shade val="15000"/>
+            </a:schemeClr>
+          </a:lnRef>
+          <a:fillRef idx="1">
+            <a:schemeClr val="accent1"/>
+          </a:fillRef>
+          <a:effectRef idx="0">
+            <a:schemeClr val="accent1"/>
+          </a:effectRef>
+          <a:fontRef idx="minor">
+            <a:schemeClr val="lt1"/>
+          </a:fontRef>
+        </p:style>
+        <p:txBody>
+          <a:bodyPr rtlCol="0" anchor="ctr"/>
+          <a:lstStyle/>
+          <a:p>
+            <a:pPr algn="ctr"/>
+            <a:r>
+              <a:rPr lang="en-US" sz="1000" dirty="0"/>
+              <a:t>FC Layer</a:t>
+            </a:r>
+          </a:p>
+        </p:txBody>
+      </p:sp>
+      <p:sp>
+        <p:nvSpPr>
+          <p:cNvPr id="8" name="Oval 7">
+            <a:extLst>
+              <a:ext uri="{FF2B5EF4-FFF2-40B4-BE49-F238E27FC236}">
+                <a16:creationId xmlns:a16="http://schemas.microsoft.com/office/drawing/2014/main" id="{B09E9743-390E-E56E-BBD4-8A26092F6E48}"/>
+              </a:ext>
+            </a:extLst>
+          </p:cNvPr>
+          <p:cNvSpPr/>
+          <p:nvPr/>
+        </p:nvSpPr>
+        <p:spPr>
+          <a:xfrm>
+            <a:off x="10453114" y="364797"/>
+            <a:ext cx="813816" cy="731520"/>
+          </a:xfrm>
+          <a:prstGeom prst="ellipse">
+            <a:avLst/>
+          </a:prstGeom>
+        </p:spPr>
+        <p:style>
+          <a:lnRef idx="2">
+            <a:schemeClr val="accent1">
+              <a:shade val="15000"/>
+            </a:schemeClr>
+          </a:lnRef>
+          <a:fillRef idx="1">
+            <a:schemeClr val="accent1"/>
+          </a:fillRef>
+          <a:effectRef idx="0">
+            <a:schemeClr val="accent1"/>
+          </a:effectRef>
+          <a:fontRef idx="minor">
+            <a:schemeClr val="lt1"/>
+          </a:fontRef>
+        </p:style>
+        <p:txBody>
+          <a:bodyPr rtlCol="0" anchor="ctr"/>
+          <a:lstStyle/>
+          <a:p>
+            <a:pPr algn="ctr"/>
+            <a:r>
+              <a:rPr lang="en-US" dirty="0"/>
+              <a:t>0/1</a:t>
+            </a:r>
+          </a:p>
+        </p:txBody>
+      </p:sp>
+      <p:sp>
+        <p:nvSpPr>
+          <p:cNvPr id="9" name="Oval 8">
+            <a:extLst>
+              <a:ext uri="{FF2B5EF4-FFF2-40B4-BE49-F238E27FC236}">
+                <a16:creationId xmlns:a16="http://schemas.microsoft.com/office/drawing/2014/main" id="{0BAF2EB7-DB00-05F8-0F27-29F2F44F7B2E}"/>
+              </a:ext>
+            </a:extLst>
+          </p:cNvPr>
+          <p:cNvSpPr/>
+          <p:nvPr/>
+        </p:nvSpPr>
+        <p:spPr>
+          <a:xfrm>
+            <a:off x="10425682" y="2179881"/>
+            <a:ext cx="813816" cy="731520"/>
+          </a:xfrm>
+          <a:prstGeom prst="ellipse">
+            <a:avLst/>
+          </a:prstGeom>
+        </p:spPr>
+        <p:style>
+          <a:lnRef idx="2">
+            <a:schemeClr val="accent1">
+              <a:shade val="15000"/>
+            </a:schemeClr>
+          </a:lnRef>
+          <a:fillRef idx="1">
+            <a:schemeClr val="accent1"/>
+          </a:fillRef>
+          <a:effectRef idx="0">
+            <a:schemeClr val="accent1"/>
+          </a:effectRef>
+          <a:fontRef idx="minor">
+            <a:schemeClr val="lt1"/>
+          </a:fontRef>
+        </p:style>
+        <p:txBody>
+          <a:bodyPr rtlCol="0" anchor="ctr"/>
+          <a:lstStyle/>
+          <a:p>
+            <a:pPr algn="ctr"/>
+            <a:r>
+              <a:rPr lang="en-US" dirty="0"/>
+              <a:t>0/1</a:t>
+            </a:r>
+          </a:p>
+        </p:txBody>
+      </p:sp>
+      <p:pic>
+        <p:nvPicPr>
+          <p:cNvPr id="13" name="Picture 12" descr="An ultrasound of a baby&#10;&#10;AI-generated content may be incorrect.">
+            <a:extLst>
+              <a:ext uri="{FF2B5EF4-FFF2-40B4-BE49-F238E27FC236}">
+                <a16:creationId xmlns:a16="http://schemas.microsoft.com/office/drawing/2014/main" id="{6DCBEF99-4CEB-4903-A943-6E5D48D42ED7}"/>
+              </a:ext>
+            </a:extLst>
+          </p:cNvPr>
+          <p:cNvPicPr>
+            <a:picLocks noChangeAspect="1"/>
+          </p:cNvPicPr>
+          <p:nvPr/>
+        </p:nvPicPr>
+        <p:blipFill>
+          <a:blip r:embed="rId2">
+            <a:extLst>
+              <a:ext uri="{28A0092B-C50C-407E-A947-70E740481C1C}">
+                <a14:useLocalDpi xmlns:a14="http://schemas.microsoft.com/office/drawing/2010/main" val="0"/>
+              </a:ext>
+            </a:extLst>
+          </a:blip>
+          <a:stretch>
+            <a:fillRect/>
+          </a:stretch>
+        </p:blipFill>
+        <p:spPr>
+          <a:xfrm>
+            <a:off x="5597650" y="269571"/>
+            <a:ext cx="960120" cy="921972"/>
+          </a:xfrm>
+          <a:prstGeom prst="rect">
+            <a:avLst/>
+          </a:prstGeom>
+        </p:spPr>
+      </p:pic>
+      <p:pic>
+        <p:nvPicPr>
+          <p:cNvPr id="14" name="Picture 13" descr="An ultrasound of a baby&#10;&#10;AI-generated content may be incorrect.">
+            <a:extLst>
+              <a:ext uri="{FF2B5EF4-FFF2-40B4-BE49-F238E27FC236}">
+                <a16:creationId xmlns:a16="http://schemas.microsoft.com/office/drawing/2014/main" id="{50D08A09-A15E-A2E9-C7A8-694278248D47}"/>
+              </a:ext>
+            </a:extLst>
+          </p:cNvPr>
+          <p:cNvPicPr>
+            <a:picLocks noChangeAspect="1"/>
+          </p:cNvPicPr>
+          <p:nvPr/>
+        </p:nvPicPr>
+        <p:blipFill>
+          <a:blip r:embed="rId2">
+            <a:extLst>
+              <a:ext uri="{28A0092B-C50C-407E-A947-70E740481C1C}">
+                <a14:useLocalDpi xmlns:a14="http://schemas.microsoft.com/office/drawing/2010/main" val="0"/>
+              </a:ext>
+            </a:extLst>
+          </a:blip>
+          <a:stretch>
+            <a:fillRect/>
+          </a:stretch>
+        </p:blipFill>
+        <p:spPr>
+          <a:xfrm>
+            <a:off x="5597650" y="2084655"/>
+            <a:ext cx="960120" cy="921972"/>
+          </a:xfrm>
+          <a:prstGeom prst="rect">
+            <a:avLst/>
+          </a:prstGeom>
+        </p:spPr>
+      </p:pic>
+      <p:cxnSp>
+        <p:nvCxnSpPr>
+          <p:cNvPr id="16" name="Straight Arrow Connector 15">
+            <a:extLst>
+              <a:ext uri="{FF2B5EF4-FFF2-40B4-BE49-F238E27FC236}">
+                <a16:creationId xmlns:a16="http://schemas.microsoft.com/office/drawing/2014/main" id="{D96B5008-2D86-DA6C-BAF6-C84A56FB506E}"/>
+              </a:ext>
+            </a:extLst>
+          </p:cNvPr>
+          <p:cNvCxnSpPr>
+            <a:stCxn id="13" idx="3"/>
+            <a:endCxn id="4" idx="0"/>
+          </p:cNvCxnSpPr>
+          <p:nvPr/>
+        </p:nvCxnSpPr>
+        <p:spPr>
+          <a:xfrm>
+            <a:off x="6557770" y="730557"/>
+            <a:ext cx="630936" cy="0"/>
+          </a:xfrm>
+          <a:prstGeom prst="straightConnector1">
+            <a:avLst/>
+          </a:prstGeom>
+          <a:ln>
+            <a:tailEnd type="triangle"/>
+          </a:ln>
+        </p:spPr>
+        <p:style>
+          <a:lnRef idx="2">
+            <a:schemeClr val="accent1"/>
+          </a:lnRef>
+          <a:fillRef idx="0">
+            <a:schemeClr val="accent1"/>
+          </a:fillRef>
+          <a:effectRef idx="1">
+            <a:schemeClr val="accent1"/>
+          </a:effectRef>
+          <a:fontRef idx="minor">
+            <a:schemeClr val="tx1"/>
+          </a:fontRef>
+        </p:style>
+      </p:cxnSp>
+      <p:cxnSp>
+        <p:nvCxnSpPr>
+          <p:cNvPr id="19" name="Straight Arrow Connector 18">
+            <a:extLst>
+              <a:ext uri="{FF2B5EF4-FFF2-40B4-BE49-F238E27FC236}">
+                <a16:creationId xmlns:a16="http://schemas.microsoft.com/office/drawing/2014/main" id="{0F90B415-8694-59F3-3A78-A5E04C5AFF74}"/>
+              </a:ext>
+            </a:extLst>
+          </p:cNvPr>
+          <p:cNvCxnSpPr>
+            <a:stCxn id="4" idx="2"/>
+            <a:endCxn id="6" idx="1"/>
+          </p:cNvCxnSpPr>
+          <p:nvPr/>
+        </p:nvCxnSpPr>
+        <p:spPr>
+          <a:xfrm>
+            <a:off x="8724898" y="730557"/>
+            <a:ext cx="489204" cy="0"/>
+          </a:xfrm>
+          <a:prstGeom prst="straightConnector1">
+            <a:avLst/>
+          </a:prstGeom>
+          <a:ln>
+            <a:tailEnd type="triangle"/>
+          </a:ln>
+        </p:spPr>
+        <p:style>
+          <a:lnRef idx="2">
+            <a:schemeClr val="accent1"/>
+          </a:lnRef>
+          <a:fillRef idx="0">
+            <a:schemeClr val="accent1"/>
+          </a:fillRef>
+          <a:effectRef idx="1">
+            <a:schemeClr val="accent1"/>
+          </a:effectRef>
+          <a:fontRef idx="minor">
+            <a:schemeClr val="tx1"/>
+          </a:fontRef>
+        </p:style>
+      </p:cxnSp>
+      <p:cxnSp>
+        <p:nvCxnSpPr>
+          <p:cNvPr id="21" name="Straight Arrow Connector 20">
+            <a:extLst>
+              <a:ext uri="{FF2B5EF4-FFF2-40B4-BE49-F238E27FC236}">
+                <a16:creationId xmlns:a16="http://schemas.microsoft.com/office/drawing/2014/main" id="{340C436D-E98A-BC64-C185-242F6DAE2EFD}"/>
+              </a:ext>
+            </a:extLst>
+          </p:cNvPr>
+          <p:cNvCxnSpPr>
+            <a:cxnSpLocks/>
+            <a:stCxn id="6" idx="3"/>
+            <a:endCxn id="8" idx="2"/>
+          </p:cNvCxnSpPr>
+          <p:nvPr/>
+        </p:nvCxnSpPr>
+        <p:spPr>
+          <a:xfrm>
+            <a:off x="9826750" y="730557"/>
+            <a:ext cx="626364" cy="0"/>
+          </a:xfrm>
+          <a:prstGeom prst="straightConnector1">
+            <a:avLst/>
+          </a:prstGeom>
+          <a:ln>
+            <a:tailEnd type="triangle"/>
+          </a:ln>
+        </p:spPr>
+        <p:style>
+          <a:lnRef idx="2">
+            <a:schemeClr val="accent1"/>
+          </a:lnRef>
+          <a:fillRef idx="0">
+            <a:schemeClr val="accent1"/>
+          </a:fillRef>
+          <a:effectRef idx="1">
+            <a:schemeClr val="accent1"/>
+          </a:effectRef>
+          <a:fontRef idx="minor">
+            <a:schemeClr val="tx1"/>
+          </a:fontRef>
+        </p:style>
+      </p:cxnSp>
+      <p:cxnSp>
+        <p:nvCxnSpPr>
+          <p:cNvPr id="26" name="Straight Arrow Connector 25">
+            <a:extLst>
+              <a:ext uri="{FF2B5EF4-FFF2-40B4-BE49-F238E27FC236}">
+                <a16:creationId xmlns:a16="http://schemas.microsoft.com/office/drawing/2014/main" id="{24824012-FF38-3B13-BF34-D9C9A9FD391B}"/>
+              </a:ext>
+            </a:extLst>
+          </p:cNvPr>
+          <p:cNvCxnSpPr>
+            <a:cxnSpLocks/>
+            <a:stCxn id="14" idx="3"/>
+            <a:endCxn id="5" idx="0"/>
+          </p:cNvCxnSpPr>
+          <p:nvPr/>
+        </p:nvCxnSpPr>
+        <p:spPr>
+          <a:xfrm>
+            <a:off x="6557770" y="2545641"/>
+            <a:ext cx="630936" cy="0"/>
+          </a:xfrm>
+          <a:prstGeom prst="straightConnector1">
+            <a:avLst/>
+          </a:prstGeom>
+          <a:ln>
+            <a:tailEnd type="triangle"/>
+          </a:ln>
+        </p:spPr>
+        <p:style>
+          <a:lnRef idx="2">
+            <a:schemeClr val="accent1"/>
+          </a:lnRef>
+          <a:fillRef idx="0">
+            <a:schemeClr val="accent1"/>
+          </a:fillRef>
+          <a:effectRef idx="1">
+            <a:schemeClr val="accent1"/>
+          </a:effectRef>
+          <a:fontRef idx="minor">
+            <a:schemeClr val="tx1"/>
+          </a:fontRef>
+        </p:style>
+      </p:cxnSp>
+      <p:cxnSp>
+        <p:nvCxnSpPr>
+          <p:cNvPr id="28" name="Straight Arrow Connector 27">
+            <a:extLst>
+              <a:ext uri="{FF2B5EF4-FFF2-40B4-BE49-F238E27FC236}">
+                <a16:creationId xmlns:a16="http://schemas.microsoft.com/office/drawing/2014/main" id="{E6BA0591-15B1-CE57-5A42-8E4E35357820}"/>
+              </a:ext>
+            </a:extLst>
+          </p:cNvPr>
+          <p:cNvCxnSpPr>
+            <a:cxnSpLocks/>
+            <a:stCxn id="5" idx="2"/>
+            <a:endCxn id="7" idx="1"/>
+          </p:cNvCxnSpPr>
+          <p:nvPr/>
+        </p:nvCxnSpPr>
+        <p:spPr>
+          <a:xfrm>
+            <a:off x="8724898" y="2545641"/>
+            <a:ext cx="489204" cy="0"/>
+          </a:xfrm>
+          <a:prstGeom prst="straightConnector1">
+            <a:avLst/>
+          </a:prstGeom>
+          <a:ln>
+            <a:tailEnd type="triangle"/>
+          </a:ln>
+        </p:spPr>
+        <p:style>
+          <a:lnRef idx="2">
+            <a:schemeClr val="accent1"/>
+          </a:lnRef>
+          <a:fillRef idx="0">
+            <a:schemeClr val="accent1"/>
+          </a:fillRef>
+          <a:effectRef idx="1">
+            <a:schemeClr val="accent1"/>
+          </a:effectRef>
+          <a:fontRef idx="minor">
+            <a:schemeClr val="tx1"/>
+          </a:fontRef>
+        </p:style>
+      </p:cxnSp>
+      <p:cxnSp>
+        <p:nvCxnSpPr>
+          <p:cNvPr id="30" name="Straight Arrow Connector 29">
+            <a:extLst>
+              <a:ext uri="{FF2B5EF4-FFF2-40B4-BE49-F238E27FC236}">
+                <a16:creationId xmlns:a16="http://schemas.microsoft.com/office/drawing/2014/main" id="{3513FA4A-1A4B-4BC3-7CB1-AF08F941FFD9}"/>
+              </a:ext>
+            </a:extLst>
+          </p:cNvPr>
+          <p:cNvCxnSpPr>
+            <a:cxnSpLocks/>
+            <a:stCxn id="7" idx="3"/>
+            <a:endCxn id="9" idx="2"/>
+          </p:cNvCxnSpPr>
+          <p:nvPr/>
+        </p:nvCxnSpPr>
+        <p:spPr>
+          <a:xfrm>
+            <a:off x="9826750" y="2545641"/>
+            <a:ext cx="598932" cy="0"/>
+          </a:xfrm>
+          <a:prstGeom prst="straightConnector1">
+            <a:avLst/>
+          </a:prstGeom>
+          <a:ln>
+            <a:tailEnd type="triangle"/>
+          </a:ln>
+        </p:spPr>
+        <p:style>
+          <a:lnRef idx="2">
+            <a:schemeClr val="accent1"/>
+          </a:lnRef>
+          <a:fillRef idx="0">
+            <a:schemeClr val="accent1"/>
+          </a:fillRef>
+          <a:effectRef idx="1">
+            <a:schemeClr val="accent1"/>
+          </a:effectRef>
+          <a:fontRef idx="minor">
+            <a:schemeClr val="tx1"/>
+          </a:fontRef>
+        </p:style>
+      </p:cxnSp>
+      <p:sp>
+        <p:nvSpPr>
+          <p:cNvPr id="32" name="TextBox 31">
+            <a:extLst>
+              <a:ext uri="{FF2B5EF4-FFF2-40B4-BE49-F238E27FC236}">
+                <a16:creationId xmlns:a16="http://schemas.microsoft.com/office/drawing/2014/main" id="{6CD8523D-011F-06EC-D09A-20EB49BADCD8}"/>
+              </a:ext>
+            </a:extLst>
+          </p:cNvPr>
+          <p:cNvSpPr txBox="1"/>
+          <p:nvPr/>
+        </p:nvSpPr>
+        <p:spPr>
+          <a:xfrm>
+            <a:off x="7312150" y="530502"/>
+            <a:ext cx="1106424" cy="553998"/>
+          </a:xfrm>
+          <a:prstGeom prst="rect">
+            <a:avLst/>
+          </a:prstGeom>
+          <a:noFill/>
+        </p:spPr>
+        <p:txBody>
+          <a:bodyPr wrap="square" rtlCol="0">
+            <a:spAutoFit/>
+          </a:bodyPr>
+          <a:lstStyle/>
+          <a:p>
+            <a:pPr algn="ctr"/>
+            <a:r>
+              <a:rPr lang="en-US" sz="1000" dirty="0">
+                <a:solidFill>
+                  <a:schemeClr val="bg1"/>
+                </a:solidFill>
+              </a:rPr>
+              <a:t>Pretrained Encoder</a:t>
+            </a:r>
+          </a:p>
+          <a:p>
+            <a:pPr algn="ctr"/>
+            <a:r>
+              <a:rPr lang="en-US" sz="1000" dirty="0">
+                <a:solidFill>
+                  <a:schemeClr val="bg1"/>
+                </a:solidFill>
+              </a:rPr>
+              <a:t>(Frozen)</a:t>
+            </a:r>
+          </a:p>
+        </p:txBody>
+      </p:sp>
+      <p:sp>
+        <p:nvSpPr>
+          <p:cNvPr id="34" name="TextBox 33">
+            <a:extLst>
+              <a:ext uri="{FF2B5EF4-FFF2-40B4-BE49-F238E27FC236}">
+                <a16:creationId xmlns:a16="http://schemas.microsoft.com/office/drawing/2014/main" id="{D1410E09-8755-3320-0B00-3AE1C378AE7A}"/>
+              </a:ext>
+            </a:extLst>
+          </p:cNvPr>
+          <p:cNvSpPr txBox="1"/>
+          <p:nvPr/>
+        </p:nvSpPr>
+        <p:spPr>
+          <a:xfrm>
+            <a:off x="7364728" y="2345586"/>
+            <a:ext cx="1106424" cy="553998"/>
+          </a:xfrm>
+          <a:prstGeom prst="rect">
+            <a:avLst/>
+          </a:prstGeom>
+          <a:noFill/>
+        </p:spPr>
+        <p:txBody>
+          <a:bodyPr wrap="square" rtlCol="0">
+            <a:spAutoFit/>
+          </a:bodyPr>
+          <a:lstStyle/>
+          <a:p>
+            <a:pPr algn="ctr"/>
+            <a:r>
+              <a:rPr lang="en-US" sz="1000" dirty="0">
+                <a:solidFill>
+                  <a:schemeClr val="bg1"/>
+                </a:solidFill>
+              </a:rPr>
+              <a:t> Encoder</a:t>
+            </a:r>
+          </a:p>
+          <a:p>
+            <a:pPr algn="ctr"/>
+            <a:r>
+              <a:rPr lang="en-US" sz="1000" dirty="0">
+                <a:solidFill>
+                  <a:schemeClr val="bg1"/>
+                </a:solidFill>
+              </a:rPr>
+              <a:t>From Scratch</a:t>
+            </a:r>
+          </a:p>
+          <a:p>
+            <a:pPr algn="ctr"/>
+            <a:r>
+              <a:rPr lang="en-US" sz="1000" dirty="0">
+                <a:solidFill>
+                  <a:schemeClr val="bg1"/>
+                </a:solidFill>
+              </a:rPr>
+              <a:t>(Trainable)</a:t>
+            </a:r>
+          </a:p>
+        </p:txBody>
+      </p:sp>
+      <p:sp>
+        <p:nvSpPr>
+          <p:cNvPr id="22" name="TextBox 21">
+            <a:extLst>
+              <a:ext uri="{FF2B5EF4-FFF2-40B4-BE49-F238E27FC236}">
+                <a16:creationId xmlns:a16="http://schemas.microsoft.com/office/drawing/2014/main" id="{00E6721E-04D8-E507-ED38-9E9E50D9D66C}"/>
+              </a:ext>
+            </a:extLst>
+          </p:cNvPr>
+          <p:cNvSpPr txBox="1"/>
+          <p:nvPr/>
+        </p:nvSpPr>
+        <p:spPr>
+          <a:xfrm>
+            <a:off x="162090" y="6382866"/>
+            <a:ext cx="5781510" cy="369332"/>
+          </a:xfrm>
+          <a:prstGeom prst="rect">
+            <a:avLst/>
+          </a:prstGeom>
+          <a:noFill/>
+        </p:spPr>
+        <p:txBody>
+          <a:bodyPr wrap="square" rtlCol="0">
+            <a:spAutoFit/>
+          </a:bodyPr>
+          <a:lstStyle/>
+          <a:p>
+            <a:pPr algn="ctr"/>
+            <a:r>
+              <a:rPr lang="en-US" dirty="0"/>
+              <a:t>Test Result on 5 fold models</a:t>
+            </a:r>
+          </a:p>
+        </p:txBody>
+      </p:sp>
+      <p:sp>
+        <p:nvSpPr>
+          <p:cNvPr id="10" name="Oval 9">
+            <a:extLst>
+              <a:ext uri="{FF2B5EF4-FFF2-40B4-BE49-F238E27FC236}">
+                <a16:creationId xmlns:a16="http://schemas.microsoft.com/office/drawing/2014/main" id="{93F5E3B6-FDA2-7F15-F78E-62A8291478DA}"/>
+              </a:ext>
+            </a:extLst>
+          </p:cNvPr>
+          <p:cNvSpPr/>
+          <p:nvPr/>
+        </p:nvSpPr>
+        <p:spPr>
+          <a:xfrm>
+            <a:off x="11382752" y="3114495"/>
+            <a:ext cx="726948" cy="580644"/>
+          </a:xfrm>
+          <a:prstGeom prst="ellipse">
+            <a:avLst/>
+          </a:prstGeom>
+        </p:spPr>
+        <p:style>
+          <a:lnRef idx="2">
+            <a:schemeClr val="accent1">
+              <a:shade val="15000"/>
+            </a:schemeClr>
+          </a:lnRef>
+          <a:fillRef idx="1">
+            <a:schemeClr val="accent1"/>
+          </a:fillRef>
+          <a:effectRef idx="0">
+            <a:schemeClr val="accent1"/>
+          </a:effectRef>
+          <a:fontRef idx="minor">
+            <a:schemeClr val="lt1"/>
+          </a:fontRef>
+        </p:style>
+        <p:txBody>
+          <a:bodyPr rtlCol="0" anchor="ctr"/>
+          <a:lstStyle/>
+          <a:p>
+            <a:pPr algn="ctr"/>
+            <a:r>
+              <a:rPr lang="en-US" dirty="0"/>
+              <a:t>0/1</a:t>
+            </a:r>
+          </a:p>
+        </p:txBody>
+      </p:sp>
+      <p:cxnSp>
+        <p:nvCxnSpPr>
+          <p:cNvPr id="24" name="Straight Arrow Connector 23">
+            <a:extLst>
+              <a:ext uri="{FF2B5EF4-FFF2-40B4-BE49-F238E27FC236}">
+                <a16:creationId xmlns:a16="http://schemas.microsoft.com/office/drawing/2014/main" id="{129EBDFF-4F93-BBFC-6E72-E931BDCE861B}"/>
+              </a:ext>
+            </a:extLst>
+          </p:cNvPr>
+          <p:cNvCxnSpPr>
+            <a:cxnSpLocks/>
+            <a:stCxn id="5" idx="2"/>
+            <a:endCxn id="6" idx="1"/>
+          </p:cNvCxnSpPr>
+          <p:nvPr/>
+        </p:nvCxnSpPr>
+        <p:spPr>
+          <a:xfrm flipV="1">
+            <a:off x="8724898" y="730557"/>
+            <a:ext cx="489204" cy="1815084"/>
+          </a:xfrm>
+          <a:prstGeom prst="straightConnector1">
+            <a:avLst/>
+          </a:prstGeom>
+          <a:ln>
+            <a:tailEnd type="triangle"/>
+          </a:ln>
+        </p:spPr>
+        <p:style>
+          <a:lnRef idx="2">
+            <a:schemeClr val="accent1"/>
+          </a:lnRef>
+          <a:fillRef idx="0">
+            <a:schemeClr val="accent1"/>
+          </a:fillRef>
+          <a:effectRef idx="1">
+            <a:schemeClr val="accent1"/>
+          </a:effectRef>
+          <a:fontRef idx="minor">
+            <a:schemeClr val="tx1"/>
+          </a:fontRef>
+        </p:style>
+      </p:cxnSp>
+      <p:cxnSp>
+        <p:nvCxnSpPr>
+          <p:cNvPr id="27" name="Straight Arrow Connector 26">
+            <a:extLst>
+              <a:ext uri="{FF2B5EF4-FFF2-40B4-BE49-F238E27FC236}">
+                <a16:creationId xmlns:a16="http://schemas.microsoft.com/office/drawing/2014/main" id="{D7FF027C-9C25-0691-BADF-FE26ABDFBE02}"/>
+              </a:ext>
+            </a:extLst>
+          </p:cNvPr>
+          <p:cNvCxnSpPr>
+            <a:stCxn id="8" idx="4"/>
+            <a:endCxn id="10" idx="0"/>
+          </p:cNvCxnSpPr>
+          <p:nvPr/>
+        </p:nvCxnSpPr>
+        <p:spPr>
+          <a:xfrm>
+            <a:off x="10860022" y="1096317"/>
+            <a:ext cx="886204" cy="2018178"/>
+          </a:xfrm>
+          <a:prstGeom prst="straightConnector1">
+            <a:avLst/>
+          </a:prstGeom>
+          <a:ln>
+            <a:tailEnd type="triangle"/>
+          </a:ln>
+        </p:spPr>
+        <p:style>
+          <a:lnRef idx="2">
+            <a:schemeClr val="accent1"/>
+          </a:lnRef>
+          <a:fillRef idx="0">
+            <a:schemeClr val="accent1"/>
+          </a:fillRef>
+          <a:effectRef idx="1">
+            <a:schemeClr val="accent1"/>
+          </a:effectRef>
+          <a:fontRef idx="minor">
+            <a:schemeClr val="tx1"/>
+          </a:fontRef>
+        </p:style>
+      </p:cxnSp>
+      <p:cxnSp>
+        <p:nvCxnSpPr>
+          <p:cNvPr id="35" name="Straight Arrow Connector 34">
+            <a:extLst>
+              <a:ext uri="{FF2B5EF4-FFF2-40B4-BE49-F238E27FC236}">
+                <a16:creationId xmlns:a16="http://schemas.microsoft.com/office/drawing/2014/main" id="{420A7E3C-00FF-EFF9-DFA5-E1A984ADC638}"/>
+              </a:ext>
+            </a:extLst>
+          </p:cNvPr>
+          <p:cNvCxnSpPr>
+            <a:cxnSpLocks/>
+            <a:stCxn id="9" idx="0"/>
+            <a:endCxn id="10" idx="4"/>
+          </p:cNvCxnSpPr>
+          <p:nvPr/>
+        </p:nvCxnSpPr>
+        <p:spPr>
+          <a:xfrm>
+            <a:off x="10832590" y="2179881"/>
+            <a:ext cx="913636" cy="1515258"/>
+          </a:xfrm>
+          <a:prstGeom prst="straightConnector1">
+            <a:avLst/>
+          </a:prstGeom>
+          <a:ln>
+            <a:tailEnd type="triangle"/>
+          </a:ln>
+        </p:spPr>
+        <p:style>
+          <a:lnRef idx="2">
+            <a:schemeClr val="accent1"/>
+          </a:lnRef>
+          <a:fillRef idx="0">
+            <a:schemeClr val="accent1"/>
+          </a:fillRef>
+          <a:effectRef idx="1">
+            <a:schemeClr val="accent1"/>
+          </a:effectRef>
+          <a:fontRef idx="minor">
+            <a:schemeClr val="tx1"/>
+          </a:fontRef>
+        </p:style>
+      </p:cxnSp>
+      <p:sp>
+        <p:nvSpPr>
+          <p:cNvPr id="17" name="Flowchart: Manual Operation 16">
+            <a:extLst>
+              <a:ext uri="{FF2B5EF4-FFF2-40B4-BE49-F238E27FC236}">
+                <a16:creationId xmlns:a16="http://schemas.microsoft.com/office/drawing/2014/main" id="{CA83A67B-99BD-3D45-4D4A-3F7663AA44BF}"/>
+              </a:ext>
+            </a:extLst>
+          </p:cNvPr>
+          <p:cNvSpPr/>
+          <p:nvPr/>
+        </p:nvSpPr>
+        <p:spPr>
+          <a:xfrm rot="16200000">
+            <a:off x="7339582" y="5149035"/>
+            <a:ext cx="1234440" cy="1536192"/>
+          </a:xfrm>
+          <a:prstGeom prst="flowChartManualOperation">
+            <a:avLst/>
+          </a:prstGeom>
+        </p:spPr>
+        <p:style>
+          <a:lnRef idx="2">
+            <a:schemeClr val="accent1">
+              <a:shade val="15000"/>
+            </a:schemeClr>
+          </a:lnRef>
+          <a:fillRef idx="1">
+            <a:schemeClr val="accent1"/>
+          </a:fillRef>
+          <a:effectRef idx="0">
+            <a:schemeClr val="accent1"/>
+          </a:effectRef>
+          <a:fontRef idx="minor">
+            <a:schemeClr val="lt1"/>
+          </a:fontRef>
+        </p:style>
+        <p:txBody>
+          <a:bodyPr rtlCol="0" anchor="ctr"/>
+          <a:lstStyle/>
+          <a:p>
+            <a:pPr algn="ctr"/>
+            <a:endParaRPr lang="en-US"/>
+          </a:p>
+        </p:txBody>
+      </p:sp>
+      <p:sp>
+        <p:nvSpPr>
+          <p:cNvPr id="18" name="Rectangle 17">
+            <a:extLst>
+              <a:ext uri="{FF2B5EF4-FFF2-40B4-BE49-F238E27FC236}">
+                <a16:creationId xmlns:a16="http://schemas.microsoft.com/office/drawing/2014/main" id="{F5AE5341-76EC-0F3D-4844-6AC9D8CC89CB}"/>
+              </a:ext>
+            </a:extLst>
+          </p:cNvPr>
+          <p:cNvSpPr/>
+          <p:nvPr/>
+        </p:nvSpPr>
+        <p:spPr>
+          <a:xfrm>
+            <a:off x="9214102" y="3695139"/>
+            <a:ext cx="612648" cy="813816"/>
+          </a:xfrm>
+          <a:prstGeom prst="rect">
+            <a:avLst/>
+          </a:prstGeom>
+        </p:spPr>
+        <p:style>
+          <a:lnRef idx="2">
+            <a:schemeClr val="accent1">
+              <a:shade val="15000"/>
+            </a:schemeClr>
+          </a:lnRef>
+          <a:fillRef idx="1">
+            <a:schemeClr val="accent1"/>
+          </a:fillRef>
+          <a:effectRef idx="0">
+            <a:schemeClr val="accent1"/>
+          </a:effectRef>
+          <a:fontRef idx="minor">
+            <a:schemeClr val="lt1"/>
+          </a:fontRef>
+        </p:style>
+        <p:txBody>
+          <a:bodyPr rtlCol="0" anchor="ctr"/>
+          <a:lstStyle/>
+          <a:p>
+            <a:pPr algn="ctr"/>
+            <a:r>
+              <a:rPr lang="en-US" sz="1000" dirty="0"/>
+              <a:t>FC Layer</a:t>
+            </a:r>
+          </a:p>
+        </p:txBody>
+      </p:sp>
+      <p:sp>
+        <p:nvSpPr>
+          <p:cNvPr id="20" name="Rectangle 19">
+            <a:extLst>
+              <a:ext uri="{FF2B5EF4-FFF2-40B4-BE49-F238E27FC236}">
+                <a16:creationId xmlns:a16="http://schemas.microsoft.com/office/drawing/2014/main" id="{7A801FBA-2C24-1B6C-AA71-95CE7428DB7D}"/>
+              </a:ext>
+            </a:extLst>
+          </p:cNvPr>
+          <p:cNvSpPr/>
+          <p:nvPr/>
+        </p:nvSpPr>
+        <p:spPr>
+          <a:xfrm>
+            <a:off x="9214102" y="5510223"/>
+            <a:ext cx="612648" cy="813816"/>
+          </a:xfrm>
+          <a:prstGeom prst="rect">
+            <a:avLst/>
+          </a:prstGeom>
+        </p:spPr>
+        <p:style>
+          <a:lnRef idx="2">
+            <a:schemeClr val="accent1">
+              <a:shade val="15000"/>
+            </a:schemeClr>
+          </a:lnRef>
+          <a:fillRef idx="1">
+            <a:schemeClr val="accent1"/>
+          </a:fillRef>
+          <a:effectRef idx="0">
+            <a:schemeClr val="accent1"/>
+          </a:effectRef>
+          <a:fontRef idx="minor">
+            <a:schemeClr val="lt1"/>
+          </a:fontRef>
+        </p:style>
+        <p:txBody>
+          <a:bodyPr rtlCol="0" anchor="ctr"/>
+          <a:lstStyle/>
+          <a:p>
+            <a:pPr algn="ctr"/>
+            <a:r>
+              <a:rPr lang="en-US" sz="1000" dirty="0"/>
+              <a:t>FC Layer</a:t>
+            </a:r>
+          </a:p>
+        </p:txBody>
+      </p:sp>
+      <p:sp>
+        <p:nvSpPr>
+          <p:cNvPr id="23" name="Oval 22">
+            <a:extLst>
+              <a:ext uri="{FF2B5EF4-FFF2-40B4-BE49-F238E27FC236}">
+                <a16:creationId xmlns:a16="http://schemas.microsoft.com/office/drawing/2014/main" id="{A2750E2B-1C95-F9C9-0B71-591C94E21D48}"/>
+              </a:ext>
+            </a:extLst>
+          </p:cNvPr>
+          <p:cNvSpPr/>
+          <p:nvPr/>
+        </p:nvSpPr>
+        <p:spPr>
+          <a:xfrm>
+            <a:off x="10453114" y="3736287"/>
+            <a:ext cx="813816" cy="731520"/>
+          </a:xfrm>
+          <a:prstGeom prst="ellipse">
+            <a:avLst/>
+          </a:prstGeom>
+        </p:spPr>
+        <p:style>
+          <a:lnRef idx="2">
+            <a:schemeClr val="accent1">
+              <a:shade val="15000"/>
+            </a:schemeClr>
+          </a:lnRef>
+          <a:fillRef idx="1">
+            <a:schemeClr val="accent1"/>
+          </a:fillRef>
+          <a:effectRef idx="0">
+            <a:schemeClr val="accent1"/>
+          </a:effectRef>
+          <a:fontRef idx="minor">
+            <a:schemeClr val="lt1"/>
+          </a:fontRef>
+        </p:style>
+        <p:txBody>
+          <a:bodyPr rtlCol="0" anchor="ctr"/>
+          <a:lstStyle/>
+          <a:p>
+            <a:pPr algn="ctr"/>
+            <a:r>
+              <a:rPr lang="en-US" dirty="0"/>
+              <a:t>0/1</a:t>
+            </a:r>
+          </a:p>
+        </p:txBody>
+      </p:sp>
+      <p:sp>
+        <p:nvSpPr>
+          <p:cNvPr id="25" name="Oval 24">
+            <a:extLst>
+              <a:ext uri="{FF2B5EF4-FFF2-40B4-BE49-F238E27FC236}">
+                <a16:creationId xmlns:a16="http://schemas.microsoft.com/office/drawing/2014/main" id="{C0D9A018-DE3C-FF3B-00A7-9DFE67ECF291}"/>
+              </a:ext>
+            </a:extLst>
+          </p:cNvPr>
+          <p:cNvSpPr/>
+          <p:nvPr/>
+        </p:nvSpPr>
+        <p:spPr>
+          <a:xfrm>
+            <a:off x="10425682" y="5551371"/>
+            <a:ext cx="813816" cy="731520"/>
+          </a:xfrm>
+          <a:prstGeom prst="ellipse">
+            <a:avLst/>
+          </a:prstGeom>
+        </p:spPr>
+        <p:style>
+          <a:lnRef idx="2">
+            <a:schemeClr val="accent1">
+              <a:shade val="15000"/>
+            </a:schemeClr>
+          </a:lnRef>
+          <a:fillRef idx="1">
+            <a:schemeClr val="accent1"/>
+          </a:fillRef>
+          <a:effectRef idx="0">
+            <a:schemeClr val="accent1"/>
+          </a:effectRef>
+          <a:fontRef idx="minor">
+            <a:schemeClr val="lt1"/>
+          </a:fontRef>
+        </p:style>
+        <p:txBody>
+          <a:bodyPr rtlCol="0" anchor="ctr"/>
+          <a:lstStyle/>
+          <a:p>
+            <a:pPr algn="ctr"/>
+            <a:r>
+              <a:rPr lang="en-US" dirty="0"/>
+              <a:t>0/1</a:t>
+            </a:r>
+          </a:p>
+        </p:txBody>
+      </p:sp>
+      <p:pic>
+        <p:nvPicPr>
+          <p:cNvPr id="29" name="Picture 28" descr="An ultrasound of a baby&#10;&#10;AI-generated content may be incorrect.">
+            <a:extLst>
+              <a:ext uri="{FF2B5EF4-FFF2-40B4-BE49-F238E27FC236}">
+                <a16:creationId xmlns:a16="http://schemas.microsoft.com/office/drawing/2014/main" id="{87E553FC-8824-3068-5800-C86129089143}"/>
+              </a:ext>
+            </a:extLst>
+          </p:cNvPr>
+          <p:cNvPicPr>
+            <a:picLocks noChangeAspect="1"/>
+          </p:cNvPicPr>
+          <p:nvPr/>
+        </p:nvPicPr>
+        <p:blipFill>
+          <a:blip r:embed="rId2">
+            <a:extLst>
+              <a:ext uri="{28A0092B-C50C-407E-A947-70E740481C1C}">
+                <a14:useLocalDpi xmlns:a14="http://schemas.microsoft.com/office/drawing/2010/main" val="0"/>
+              </a:ext>
+            </a:extLst>
+          </a:blip>
+          <a:stretch>
+            <a:fillRect/>
+          </a:stretch>
+        </p:blipFill>
+        <p:spPr>
+          <a:xfrm>
+            <a:off x="5597650" y="3641061"/>
+            <a:ext cx="960120" cy="921972"/>
+          </a:xfrm>
+          <a:prstGeom prst="rect">
+            <a:avLst/>
+          </a:prstGeom>
+        </p:spPr>
+      </p:pic>
+      <p:pic>
+        <p:nvPicPr>
+          <p:cNvPr id="31" name="Picture 30" descr="An ultrasound of a baby&#10;&#10;AI-generated content may be incorrect.">
+            <a:extLst>
+              <a:ext uri="{FF2B5EF4-FFF2-40B4-BE49-F238E27FC236}">
+                <a16:creationId xmlns:a16="http://schemas.microsoft.com/office/drawing/2014/main" id="{D0C1FB53-C839-6C81-A6CA-CC011319E7E4}"/>
+              </a:ext>
+            </a:extLst>
+          </p:cNvPr>
+          <p:cNvPicPr>
+            <a:picLocks noChangeAspect="1"/>
+          </p:cNvPicPr>
+          <p:nvPr/>
+        </p:nvPicPr>
+        <p:blipFill>
+          <a:blip r:embed="rId2">
+            <a:extLst>
+              <a:ext uri="{28A0092B-C50C-407E-A947-70E740481C1C}">
+                <a14:useLocalDpi xmlns:a14="http://schemas.microsoft.com/office/drawing/2010/main" val="0"/>
+              </a:ext>
+            </a:extLst>
+          </a:blip>
+          <a:stretch>
+            <a:fillRect/>
+          </a:stretch>
+        </p:blipFill>
+        <p:spPr>
+          <a:xfrm>
+            <a:off x="5597650" y="5456145"/>
+            <a:ext cx="960120" cy="921972"/>
+          </a:xfrm>
+          <a:prstGeom prst="rect">
+            <a:avLst/>
+          </a:prstGeom>
+        </p:spPr>
+      </p:pic>
+      <p:cxnSp>
+        <p:nvCxnSpPr>
+          <p:cNvPr id="33" name="Straight Arrow Connector 32">
+            <a:extLst>
+              <a:ext uri="{FF2B5EF4-FFF2-40B4-BE49-F238E27FC236}">
+                <a16:creationId xmlns:a16="http://schemas.microsoft.com/office/drawing/2014/main" id="{BC1BB6C8-968A-3D44-656C-E3616CC8681A}"/>
+              </a:ext>
+            </a:extLst>
+          </p:cNvPr>
+          <p:cNvCxnSpPr>
+            <a:stCxn id="29" idx="3"/>
+          </p:cNvCxnSpPr>
+          <p:nvPr/>
+        </p:nvCxnSpPr>
+        <p:spPr>
+          <a:xfrm>
+            <a:off x="6557770" y="4102047"/>
+            <a:ext cx="630936" cy="0"/>
+          </a:xfrm>
+          <a:prstGeom prst="straightConnector1">
+            <a:avLst/>
+          </a:prstGeom>
+          <a:ln>
+            <a:tailEnd type="triangle"/>
+          </a:ln>
+        </p:spPr>
+        <p:style>
+          <a:lnRef idx="2">
+            <a:schemeClr val="accent1"/>
+          </a:lnRef>
+          <a:fillRef idx="0">
+            <a:schemeClr val="accent1"/>
+          </a:fillRef>
+          <a:effectRef idx="1">
+            <a:schemeClr val="accent1"/>
+          </a:effectRef>
+          <a:fontRef idx="minor">
+            <a:schemeClr val="tx1"/>
+          </a:fontRef>
+        </p:style>
+      </p:cxnSp>
+      <p:cxnSp>
+        <p:nvCxnSpPr>
+          <p:cNvPr id="36" name="Straight Arrow Connector 35">
+            <a:extLst>
+              <a:ext uri="{FF2B5EF4-FFF2-40B4-BE49-F238E27FC236}">
+                <a16:creationId xmlns:a16="http://schemas.microsoft.com/office/drawing/2014/main" id="{23C87D05-ED14-9BCA-FEC0-34C50AB5453C}"/>
+              </a:ext>
+            </a:extLst>
+          </p:cNvPr>
+          <p:cNvCxnSpPr>
+            <a:endCxn id="18" idx="1"/>
+          </p:cNvCxnSpPr>
+          <p:nvPr/>
+        </p:nvCxnSpPr>
+        <p:spPr>
+          <a:xfrm>
+            <a:off x="8724898" y="4102047"/>
+            <a:ext cx="489204" cy="0"/>
+          </a:xfrm>
+          <a:prstGeom prst="straightConnector1">
+            <a:avLst/>
+          </a:prstGeom>
+          <a:ln>
+            <a:tailEnd type="triangle"/>
+          </a:ln>
+        </p:spPr>
+        <p:style>
+          <a:lnRef idx="2">
+            <a:schemeClr val="accent1"/>
+          </a:lnRef>
+          <a:fillRef idx="0">
+            <a:schemeClr val="accent1"/>
+          </a:fillRef>
+          <a:effectRef idx="1">
+            <a:schemeClr val="accent1"/>
+          </a:effectRef>
+          <a:fontRef idx="minor">
+            <a:schemeClr val="tx1"/>
+          </a:fontRef>
+        </p:style>
+      </p:cxnSp>
+      <p:cxnSp>
+        <p:nvCxnSpPr>
+          <p:cNvPr id="37" name="Straight Arrow Connector 36">
+            <a:extLst>
+              <a:ext uri="{FF2B5EF4-FFF2-40B4-BE49-F238E27FC236}">
+                <a16:creationId xmlns:a16="http://schemas.microsoft.com/office/drawing/2014/main" id="{DA69D456-D829-1A47-EC9A-49F936DBC29B}"/>
+              </a:ext>
+            </a:extLst>
+          </p:cNvPr>
+          <p:cNvCxnSpPr>
+            <a:cxnSpLocks/>
+            <a:stCxn id="18" idx="3"/>
+            <a:endCxn id="23" idx="2"/>
+          </p:cNvCxnSpPr>
+          <p:nvPr/>
+        </p:nvCxnSpPr>
+        <p:spPr>
+          <a:xfrm>
+            <a:off x="9826750" y="4102047"/>
+            <a:ext cx="626364" cy="0"/>
+          </a:xfrm>
+          <a:prstGeom prst="straightConnector1">
+            <a:avLst/>
+          </a:prstGeom>
+          <a:ln>
+            <a:tailEnd type="triangle"/>
+          </a:ln>
+        </p:spPr>
+        <p:style>
+          <a:lnRef idx="2">
+            <a:schemeClr val="accent1"/>
+          </a:lnRef>
+          <a:fillRef idx="0">
+            <a:schemeClr val="accent1"/>
+          </a:fillRef>
+          <a:effectRef idx="1">
+            <a:schemeClr val="accent1"/>
+          </a:effectRef>
+          <a:fontRef idx="minor">
+            <a:schemeClr val="tx1"/>
+          </a:fontRef>
+        </p:style>
+      </p:cxnSp>
+      <p:cxnSp>
+        <p:nvCxnSpPr>
+          <p:cNvPr id="38" name="Straight Arrow Connector 37">
+            <a:extLst>
+              <a:ext uri="{FF2B5EF4-FFF2-40B4-BE49-F238E27FC236}">
+                <a16:creationId xmlns:a16="http://schemas.microsoft.com/office/drawing/2014/main" id="{421DC1EE-6176-CF02-705A-C1D2D5DB5A47}"/>
+              </a:ext>
+            </a:extLst>
+          </p:cNvPr>
+          <p:cNvCxnSpPr>
+            <a:cxnSpLocks/>
+            <a:stCxn id="31" idx="3"/>
+            <a:endCxn id="17" idx="0"/>
+          </p:cNvCxnSpPr>
+          <p:nvPr/>
+        </p:nvCxnSpPr>
+        <p:spPr>
+          <a:xfrm>
+            <a:off x="6557770" y="5917131"/>
+            <a:ext cx="630936" cy="0"/>
+          </a:xfrm>
+          <a:prstGeom prst="straightConnector1">
+            <a:avLst/>
+          </a:prstGeom>
+          <a:ln>
+            <a:tailEnd type="triangle"/>
+          </a:ln>
+        </p:spPr>
+        <p:style>
+          <a:lnRef idx="2">
+            <a:schemeClr val="accent1"/>
+          </a:lnRef>
+          <a:fillRef idx="0">
+            <a:schemeClr val="accent1"/>
+          </a:fillRef>
+          <a:effectRef idx="1">
+            <a:schemeClr val="accent1"/>
+          </a:effectRef>
+          <a:fontRef idx="minor">
+            <a:schemeClr val="tx1"/>
+          </a:fontRef>
+        </p:style>
+      </p:cxnSp>
+      <p:cxnSp>
+        <p:nvCxnSpPr>
+          <p:cNvPr id="39" name="Straight Arrow Connector 38">
+            <a:extLst>
+              <a:ext uri="{FF2B5EF4-FFF2-40B4-BE49-F238E27FC236}">
+                <a16:creationId xmlns:a16="http://schemas.microsoft.com/office/drawing/2014/main" id="{056D1023-6517-67A8-218D-F1798383CC39}"/>
+              </a:ext>
+            </a:extLst>
+          </p:cNvPr>
+          <p:cNvCxnSpPr>
+            <a:cxnSpLocks/>
+            <a:stCxn id="17" idx="2"/>
+            <a:endCxn id="20" idx="1"/>
+          </p:cNvCxnSpPr>
+          <p:nvPr/>
+        </p:nvCxnSpPr>
+        <p:spPr>
+          <a:xfrm>
+            <a:off x="8724898" y="5917131"/>
+            <a:ext cx="489204" cy="0"/>
+          </a:xfrm>
+          <a:prstGeom prst="straightConnector1">
+            <a:avLst/>
+          </a:prstGeom>
+          <a:ln>
+            <a:tailEnd type="triangle"/>
+          </a:ln>
+        </p:spPr>
+        <p:style>
+          <a:lnRef idx="2">
+            <a:schemeClr val="accent1"/>
+          </a:lnRef>
+          <a:fillRef idx="0">
+            <a:schemeClr val="accent1"/>
+          </a:fillRef>
+          <a:effectRef idx="1">
+            <a:schemeClr val="accent1"/>
+          </a:effectRef>
+          <a:fontRef idx="minor">
+            <a:schemeClr val="tx1"/>
+          </a:fontRef>
+        </p:style>
+      </p:cxnSp>
+      <p:cxnSp>
+        <p:nvCxnSpPr>
+          <p:cNvPr id="40" name="Straight Arrow Connector 39">
+            <a:extLst>
+              <a:ext uri="{FF2B5EF4-FFF2-40B4-BE49-F238E27FC236}">
+                <a16:creationId xmlns:a16="http://schemas.microsoft.com/office/drawing/2014/main" id="{C248A13C-2340-3FE8-0ACB-F7CF0C4E3001}"/>
+              </a:ext>
+            </a:extLst>
+          </p:cNvPr>
+          <p:cNvCxnSpPr>
+            <a:cxnSpLocks/>
+            <a:stCxn id="20" idx="3"/>
+            <a:endCxn id="25" idx="2"/>
+          </p:cNvCxnSpPr>
+          <p:nvPr/>
+        </p:nvCxnSpPr>
+        <p:spPr>
+          <a:xfrm>
+            <a:off x="9826750" y="5917131"/>
+            <a:ext cx="598932" cy="0"/>
+          </a:xfrm>
+          <a:prstGeom prst="straightConnector1">
+            <a:avLst/>
+          </a:prstGeom>
+          <a:ln>
+            <a:tailEnd type="triangle"/>
+          </a:ln>
+        </p:spPr>
+        <p:style>
+          <a:lnRef idx="2">
+            <a:schemeClr val="accent1"/>
+          </a:lnRef>
+          <a:fillRef idx="0">
+            <a:schemeClr val="accent1"/>
+          </a:fillRef>
+          <a:effectRef idx="1">
+            <a:schemeClr val="accent1"/>
+          </a:effectRef>
+          <a:fontRef idx="minor">
+            <a:schemeClr val="tx1"/>
+          </a:fontRef>
+        </p:style>
+      </p:cxnSp>
+      <p:sp>
+        <p:nvSpPr>
+          <p:cNvPr id="41" name="TextBox 40">
+            <a:extLst>
+              <a:ext uri="{FF2B5EF4-FFF2-40B4-BE49-F238E27FC236}">
+                <a16:creationId xmlns:a16="http://schemas.microsoft.com/office/drawing/2014/main" id="{7EDF819B-66DD-5640-A5C5-3E75A5DEE642}"/>
+              </a:ext>
+            </a:extLst>
+          </p:cNvPr>
+          <p:cNvSpPr txBox="1"/>
+          <p:nvPr/>
+        </p:nvSpPr>
+        <p:spPr>
+          <a:xfrm>
+            <a:off x="7061640" y="3674767"/>
+            <a:ext cx="1500759" cy="1015663"/>
+          </a:xfrm>
+          <a:prstGeom prst="rect">
+            <a:avLst/>
+          </a:prstGeom>
+          <a:noFill/>
+        </p:spPr>
+        <p:txBody>
+          <a:bodyPr wrap="square" rtlCol="0">
+            <a:spAutoFit/>
+          </a:bodyPr>
+          <a:lstStyle/>
+          <a:p>
+            <a:pPr algn="ctr"/>
+            <a:r>
+              <a:rPr lang="en-US" sz="1000" dirty="0">
+                <a:solidFill>
+                  <a:schemeClr val="bg1"/>
+                </a:solidFill>
+              </a:rPr>
+              <a:t>1. SDF-Model -&gt;</a:t>
+            </a:r>
+          </a:p>
+          <a:p>
+            <a:pPr marL="171450" indent="-171450" algn="ctr">
+              <a:buFont typeface="Wingdings" panose="05000000000000000000" pitchFamily="2" charset="2"/>
+              <a:buChar char="è"/>
+            </a:pPr>
+            <a:r>
+              <a:rPr lang="en-US" sz="1000" dirty="0">
+                <a:solidFill>
+                  <a:schemeClr val="bg1"/>
+                </a:solidFill>
+              </a:rPr>
+              <a:t>2 .Binary Boundary Mask-&gt;</a:t>
+            </a:r>
+          </a:p>
+          <a:p>
+            <a:pPr marL="171450" indent="-171450" algn="ctr">
+              <a:buFont typeface="Wingdings" panose="05000000000000000000" pitchFamily="2" charset="2"/>
+              <a:buChar char="è"/>
+            </a:pPr>
+            <a:r>
+              <a:rPr lang="en-US" sz="1000" dirty="0">
+                <a:solidFill>
+                  <a:schemeClr val="bg1"/>
+                </a:solidFill>
+              </a:rPr>
+              <a:t>3. US image within Boundary-&gt;</a:t>
+            </a:r>
+          </a:p>
+          <a:p>
+            <a:pPr marL="171450" indent="-171450" algn="ctr">
+              <a:buFont typeface="Wingdings" panose="05000000000000000000" pitchFamily="2" charset="2"/>
+              <a:buChar char="è"/>
+            </a:pPr>
+            <a:r>
+              <a:rPr lang="en-US" sz="1000" dirty="0">
+                <a:solidFill>
+                  <a:schemeClr val="bg1"/>
+                </a:solidFill>
+              </a:rPr>
+              <a:t>4. Encoder</a:t>
+            </a:r>
+          </a:p>
+        </p:txBody>
+      </p:sp>
+      <p:cxnSp>
+        <p:nvCxnSpPr>
+          <p:cNvPr id="46" name="Straight Arrow Connector 45">
+            <a:extLst>
+              <a:ext uri="{FF2B5EF4-FFF2-40B4-BE49-F238E27FC236}">
+                <a16:creationId xmlns:a16="http://schemas.microsoft.com/office/drawing/2014/main" id="{31B44CC2-6931-AFCE-12A1-6379597262A5}"/>
+              </a:ext>
+            </a:extLst>
+          </p:cNvPr>
+          <p:cNvCxnSpPr>
+            <a:cxnSpLocks/>
+            <a:stCxn id="25" idx="0"/>
+          </p:cNvCxnSpPr>
+          <p:nvPr/>
+        </p:nvCxnSpPr>
+        <p:spPr>
+          <a:xfrm flipV="1">
+            <a:off x="10832590" y="3695139"/>
+            <a:ext cx="941068" cy="1856232"/>
+          </a:xfrm>
+          <a:prstGeom prst="straightConnector1">
+            <a:avLst/>
+          </a:prstGeom>
+          <a:ln>
+            <a:tailEnd type="triangle"/>
+          </a:ln>
+        </p:spPr>
+        <p:style>
+          <a:lnRef idx="2">
+            <a:schemeClr val="accent1"/>
+          </a:lnRef>
+          <a:fillRef idx="0">
+            <a:schemeClr val="accent1"/>
+          </a:fillRef>
+          <a:effectRef idx="1">
+            <a:schemeClr val="accent1"/>
+          </a:effectRef>
+          <a:fontRef idx="minor">
+            <a:schemeClr val="tx1"/>
+          </a:fontRef>
+        </p:style>
+      </p:cxnSp>
+      <p:sp>
+        <p:nvSpPr>
+          <p:cNvPr id="56" name="TextBox 55">
+            <a:extLst>
+              <a:ext uri="{FF2B5EF4-FFF2-40B4-BE49-F238E27FC236}">
+                <a16:creationId xmlns:a16="http://schemas.microsoft.com/office/drawing/2014/main" id="{BC8248EB-DF6D-BF49-1996-4FD63CE8AC12}"/>
+              </a:ext>
+            </a:extLst>
+          </p:cNvPr>
+          <p:cNvSpPr txBox="1"/>
+          <p:nvPr/>
+        </p:nvSpPr>
+        <p:spPr>
+          <a:xfrm>
+            <a:off x="7061639" y="5405504"/>
+            <a:ext cx="1500759" cy="1015663"/>
+          </a:xfrm>
+          <a:prstGeom prst="rect">
+            <a:avLst/>
+          </a:prstGeom>
+          <a:noFill/>
+        </p:spPr>
+        <p:txBody>
+          <a:bodyPr wrap="square" rtlCol="0">
+            <a:spAutoFit/>
+          </a:bodyPr>
+          <a:lstStyle/>
+          <a:p>
+            <a:pPr algn="ctr"/>
+            <a:r>
+              <a:rPr lang="en-US" sz="1000" dirty="0">
+                <a:solidFill>
+                  <a:schemeClr val="bg1"/>
+                </a:solidFill>
+              </a:rPr>
+              <a:t>1. SDF-Model -&gt;</a:t>
+            </a:r>
+          </a:p>
+          <a:p>
+            <a:pPr marL="171450" indent="-171450" algn="ctr">
+              <a:buFont typeface="Wingdings" panose="05000000000000000000" pitchFamily="2" charset="2"/>
+              <a:buChar char="è"/>
+            </a:pPr>
+            <a:r>
+              <a:rPr lang="en-US" sz="1000" dirty="0">
+                <a:solidFill>
+                  <a:schemeClr val="bg1"/>
+                </a:solidFill>
+              </a:rPr>
+              <a:t>2 . Lesion Centre Mask-&gt;</a:t>
+            </a:r>
+          </a:p>
+          <a:p>
+            <a:pPr marL="171450" indent="-171450" algn="ctr">
+              <a:buFont typeface="Wingdings" panose="05000000000000000000" pitchFamily="2" charset="2"/>
+              <a:buChar char="è"/>
+            </a:pPr>
+            <a:r>
+              <a:rPr lang="en-US" sz="1000" dirty="0">
+                <a:solidFill>
+                  <a:schemeClr val="bg1"/>
+                </a:solidFill>
+              </a:rPr>
+              <a:t>3. US image within Lesion Center-&gt;</a:t>
+            </a:r>
+          </a:p>
+          <a:p>
+            <a:pPr marL="171450" indent="-171450" algn="ctr">
+              <a:buFont typeface="Wingdings" panose="05000000000000000000" pitchFamily="2" charset="2"/>
+              <a:buChar char="è"/>
+            </a:pPr>
+            <a:r>
+              <a:rPr lang="en-US" sz="1000" dirty="0">
+                <a:solidFill>
+                  <a:schemeClr val="bg1"/>
+                </a:solidFill>
+              </a:rPr>
+              <a:t>4. Encoder</a:t>
+            </a:r>
+          </a:p>
+        </p:txBody>
+      </p:sp>
+      <p:pic>
+        <p:nvPicPr>
+          <p:cNvPr id="12" name="Picture 11" descr="A graph of a curve&#10;&#10;AI-generated content may be incorrect.">
+            <a:extLst>
+              <a:ext uri="{FF2B5EF4-FFF2-40B4-BE49-F238E27FC236}">
+                <a16:creationId xmlns:a16="http://schemas.microsoft.com/office/drawing/2014/main" id="{BB8C0918-8777-C18E-3CCE-E7F47E971FA3}"/>
+              </a:ext>
+            </a:extLst>
+          </p:cNvPr>
+          <p:cNvPicPr>
+            <a:picLocks noChangeAspect="1"/>
+          </p:cNvPicPr>
+          <p:nvPr/>
+        </p:nvPicPr>
+        <p:blipFill>
+          <a:blip r:embed="rId3">
+            <a:extLst>
+              <a:ext uri="{28A0092B-C50C-407E-A947-70E740481C1C}">
+                <a14:useLocalDpi xmlns:a14="http://schemas.microsoft.com/office/drawing/2010/main" val="0"/>
+              </a:ext>
+            </a:extLst>
+          </a:blip>
+          <a:stretch>
+            <a:fillRect/>
+          </a:stretch>
+        </p:blipFill>
+        <p:spPr>
+          <a:xfrm>
+            <a:off x="1191366" y="3791151"/>
+            <a:ext cx="3204923" cy="2403692"/>
+          </a:xfrm>
+          <a:prstGeom prst="rect">
+            <a:avLst/>
+          </a:prstGeom>
+        </p:spPr>
+      </p:pic>
+    </p:spTree>
+    <p:extLst>
+      <p:ext uri="{BB962C8B-B14F-4D97-AF65-F5344CB8AC3E}">
+        <p14:creationId xmlns:p14="http://schemas.microsoft.com/office/powerpoint/2010/main" val="3414342946"/>
+      </p:ext>
+    </p:extLst>
+  </p:cSld>
+  <p:clrMapOvr>
+    <a:masterClrMapping/>
+  </p:clrMapOvr>
+</p:sld>
+</file>
+
+<file path=ppt/slides/slide17.xml><?xml version="1.0" encoding="utf-8"?>
+<p:sld xmlns:a="http://schemas.openxmlformats.org/drawingml/2006/main" xmlns:r="http://schemas.openxmlformats.org/officeDocument/2006/relationships" xmlns:p="http://schemas.openxmlformats.org/presentationml/2006/main">
+  <p:cSld>
+    <p:spTree>
+      <p:nvGrpSpPr>
+        <p:cNvPr id="1" name="">
+          <a:extLst>
+            <a:ext uri="{FF2B5EF4-FFF2-40B4-BE49-F238E27FC236}">
+              <a16:creationId xmlns:a16="http://schemas.microsoft.com/office/drawing/2014/main" id="{6AA24E0A-1A3F-3E1B-F185-0A5907C49937}"/>
+            </a:ext>
+          </a:extLst>
+        </p:cNvPr>
+        <p:cNvGrpSpPr/>
+        <p:nvPr/>
+      </p:nvGrpSpPr>
+      <p:grpSpPr>
+        <a:xfrm>
+          <a:off x="0" y="0"/>
+          <a:ext cx="0" cy="0"/>
+          <a:chOff x="0" y="0"/>
+          <a:chExt cx="0" cy="0"/>
+        </a:xfrm>
+      </p:grpSpPr>
+      <p:cxnSp>
+        <p:nvCxnSpPr>
+          <p:cNvPr id="45" name="Straight Arrow Connector 44">
+            <a:extLst>
+              <a:ext uri="{FF2B5EF4-FFF2-40B4-BE49-F238E27FC236}">
+                <a16:creationId xmlns:a16="http://schemas.microsoft.com/office/drawing/2014/main" id="{8FB72DFC-F6A3-CB4C-D4BB-CDEA2C0A2974}"/>
+              </a:ext>
+            </a:extLst>
+          </p:cNvPr>
+          <p:cNvCxnSpPr>
+            <a:cxnSpLocks/>
+            <a:stCxn id="23" idx="4"/>
+          </p:cNvCxnSpPr>
+          <p:nvPr/>
+        </p:nvCxnSpPr>
+        <p:spPr>
+          <a:xfrm flipV="1">
+            <a:off x="10860022" y="3114495"/>
+            <a:ext cx="913636" cy="1353312"/>
+          </a:xfrm>
+          <a:prstGeom prst="straightConnector1">
+            <a:avLst/>
+          </a:prstGeom>
+          <a:ln>
+            <a:tailEnd type="triangle"/>
+          </a:ln>
+        </p:spPr>
+        <p:style>
+          <a:lnRef idx="2">
+            <a:schemeClr val="accent1"/>
+          </a:lnRef>
+          <a:fillRef idx="0">
+            <a:schemeClr val="accent1"/>
+          </a:fillRef>
+          <a:effectRef idx="1">
+            <a:schemeClr val="accent1"/>
+          </a:effectRef>
+          <a:fontRef idx="minor">
+            <a:schemeClr val="tx1"/>
+          </a:fontRef>
+        </p:style>
+      </p:cxnSp>
+      <p:sp>
+        <p:nvSpPr>
+          <p:cNvPr id="49" name="Flowchart: Manual Operation 48">
+            <a:extLst>
+              <a:ext uri="{FF2B5EF4-FFF2-40B4-BE49-F238E27FC236}">
+                <a16:creationId xmlns:a16="http://schemas.microsoft.com/office/drawing/2014/main" id="{FDD3E2EC-F9A8-2081-FA17-15B7C9E5AFB9}"/>
+              </a:ext>
+            </a:extLst>
+          </p:cNvPr>
+          <p:cNvSpPr/>
+          <p:nvPr/>
+        </p:nvSpPr>
+        <p:spPr>
+          <a:xfrm rot="16200000">
+            <a:off x="7331960" y="3398895"/>
+            <a:ext cx="1234440" cy="1536192"/>
+          </a:xfrm>
+          <a:prstGeom prst="flowChartManualOperation">
+            <a:avLst/>
+          </a:prstGeom>
+        </p:spPr>
+        <p:style>
+          <a:lnRef idx="2">
+            <a:schemeClr val="accent1">
+              <a:shade val="15000"/>
+            </a:schemeClr>
+          </a:lnRef>
+          <a:fillRef idx="1">
+            <a:schemeClr val="accent1"/>
+          </a:fillRef>
+          <a:effectRef idx="0">
+            <a:schemeClr val="accent1"/>
+          </a:effectRef>
+          <a:fontRef idx="minor">
+            <a:schemeClr val="lt1"/>
+          </a:fontRef>
+        </p:style>
+        <p:txBody>
+          <a:bodyPr rtlCol="0" anchor="ctr"/>
+          <a:lstStyle/>
+          <a:p>
+            <a:pPr algn="ctr"/>
+            <a:endParaRPr lang="en-US" dirty="0"/>
+          </a:p>
+        </p:txBody>
+      </p:sp>
+      <p:sp>
+        <p:nvSpPr>
+          <p:cNvPr id="2" name="TextBox 1">
+            <a:extLst>
+              <a:ext uri="{FF2B5EF4-FFF2-40B4-BE49-F238E27FC236}">
+                <a16:creationId xmlns:a16="http://schemas.microsoft.com/office/drawing/2014/main" id="{67C7732B-08BC-AEF1-5099-FF7F14B2EB50}"/>
+              </a:ext>
+            </a:extLst>
+          </p:cNvPr>
+          <p:cNvSpPr txBox="1"/>
+          <p:nvPr/>
+        </p:nvSpPr>
+        <p:spPr>
+          <a:xfrm>
+            <a:off x="797050" y="714205"/>
+            <a:ext cx="2688336" cy="369332"/>
+          </a:xfrm>
+          <a:prstGeom prst="rect">
+            <a:avLst/>
+          </a:prstGeom>
+          <a:noFill/>
+        </p:spPr>
+        <p:txBody>
+          <a:bodyPr wrap="square" rtlCol="0">
+            <a:spAutoFit/>
+          </a:bodyPr>
+          <a:lstStyle/>
+          <a:p>
+            <a:r>
+              <a:rPr lang="en-US" dirty="0"/>
+              <a:t>Experiment 4.3: </a:t>
+            </a:r>
+          </a:p>
+        </p:txBody>
+      </p:sp>
+      <p:sp>
+        <p:nvSpPr>
+          <p:cNvPr id="3" name="TextBox 2">
+            <a:extLst>
+              <a:ext uri="{FF2B5EF4-FFF2-40B4-BE49-F238E27FC236}">
+                <a16:creationId xmlns:a16="http://schemas.microsoft.com/office/drawing/2014/main" id="{5C329EE3-CE34-5A49-87E8-ABD811BD98FA}"/>
+              </a:ext>
+            </a:extLst>
+          </p:cNvPr>
+          <p:cNvSpPr txBox="1"/>
+          <p:nvPr/>
+        </p:nvSpPr>
+        <p:spPr>
+          <a:xfrm>
+            <a:off x="858201" y="914425"/>
+            <a:ext cx="4502277" cy="2862322"/>
+          </a:xfrm>
+          <a:prstGeom prst="rect">
+            <a:avLst/>
+          </a:prstGeom>
+          <a:noFill/>
+        </p:spPr>
+        <p:txBody>
+          <a:bodyPr wrap="square" rtlCol="0">
+            <a:spAutoFit/>
+          </a:bodyPr>
+          <a:lstStyle/>
+          <a:p>
+            <a:endParaRPr lang="en-US" dirty="0"/>
+          </a:p>
+          <a:p>
+            <a:pPr marL="285750" indent="-285750">
+              <a:buFont typeface="Arial" panose="020B0604020202020204" pitchFamily="34" charset="0"/>
+              <a:buChar char="•"/>
+            </a:pPr>
+            <a:r>
+              <a:rPr lang="en-US" dirty="0"/>
+              <a:t>Binary Classification Setup </a:t>
+            </a:r>
+          </a:p>
+          <a:p>
+            <a:pPr marL="285750" indent="-285750">
+              <a:buFont typeface="Arial" panose="020B0604020202020204" pitchFamily="34" charset="0"/>
+              <a:buChar char="•"/>
+            </a:pPr>
+            <a:r>
+              <a:rPr lang="en-US" dirty="0"/>
+              <a:t>Classification Based on US Image Only</a:t>
+            </a:r>
+          </a:p>
+          <a:p>
+            <a:pPr marL="285750" indent="-285750">
+              <a:buFont typeface="Arial" panose="020B0604020202020204" pitchFamily="34" charset="0"/>
+              <a:buChar char="•"/>
+            </a:pPr>
+            <a:r>
+              <a:rPr lang="en-US" dirty="0"/>
+              <a:t>4 separate encoder with different types of US input </a:t>
+            </a:r>
+          </a:p>
+          <a:p>
+            <a:pPr marL="285750" indent="-285750">
+              <a:buFont typeface="Arial" panose="020B0604020202020204" pitchFamily="34" charset="0"/>
+              <a:buChar char="•"/>
+            </a:pPr>
+            <a:r>
+              <a:rPr lang="en-US" dirty="0"/>
+              <a:t>Linear layer weighted score</a:t>
+            </a:r>
+          </a:p>
+          <a:p>
+            <a:pPr marL="285750" indent="-285750">
+              <a:buFont typeface="Arial" panose="020B0604020202020204" pitchFamily="34" charset="0"/>
+              <a:buChar char="•"/>
+            </a:pPr>
+            <a:r>
+              <a:rPr lang="en-US" dirty="0" err="1"/>
+              <a:t>Asymmetrics</a:t>
+            </a:r>
+            <a:r>
+              <a:rPr lang="en-US" dirty="0"/>
+              <a:t> Loss + Focal Loss</a:t>
+            </a:r>
+          </a:p>
+          <a:p>
+            <a:pPr marL="285750" indent="-285750">
+              <a:buFont typeface="Arial" panose="020B0604020202020204" pitchFamily="34" charset="0"/>
+              <a:buChar char="•"/>
+            </a:pPr>
+            <a:r>
+              <a:rPr lang="en-US" dirty="0" err="1"/>
+              <a:t>Testset</a:t>
+            </a:r>
+            <a:r>
+              <a:rPr lang="en-US" dirty="0"/>
+              <a:t> on 4 to 20 Patient IDs:</a:t>
+            </a:r>
+          </a:p>
+          <a:p>
+            <a:pPr marL="285750" indent="-285750">
+              <a:buFont typeface="Arial" panose="020B0604020202020204" pitchFamily="34" charset="0"/>
+              <a:buChar char="•"/>
+            </a:pPr>
+            <a:endParaRPr lang="en-US" dirty="0"/>
+          </a:p>
+          <a:p>
+            <a:pPr marL="285750" indent="-285750">
+              <a:buFont typeface="Arial" panose="020B0604020202020204" pitchFamily="34" charset="0"/>
+              <a:buChar char="•"/>
+            </a:pPr>
+            <a:endParaRPr lang="en-US" dirty="0"/>
+          </a:p>
+        </p:txBody>
+      </p:sp>
+      <p:sp>
+        <p:nvSpPr>
+          <p:cNvPr id="4" name="Flowchart: Manual Operation 3">
+            <a:extLst>
+              <a:ext uri="{FF2B5EF4-FFF2-40B4-BE49-F238E27FC236}">
+                <a16:creationId xmlns:a16="http://schemas.microsoft.com/office/drawing/2014/main" id="{DB37ED34-1FFF-5445-88B4-B16C68D9DE8B}"/>
+              </a:ext>
+            </a:extLst>
+          </p:cNvPr>
+          <p:cNvSpPr/>
+          <p:nvPr/>
+        </p:nvSpPr>
+        <p:spPr>
+          <a:xfrm rot="16200000">
+            <a:off x="7339582" y="-37539"/>
+            <a:ext cx="1234440" cy="1536192"/>
+          </a:xfrm>
+          <a:prstGeom prst="flowChartManualOperation">
+            <a:avLst/>
+          </a:prstGeom>
+        </p:spPr>
+        <p:style>
+          <a:lnRef idx="2">
+            <a:schemeClr val="accent1">
+              <a:shade val="15000"/>
+            </a:schemeClr>
+          </a:lnRef>
+          <a:fillRef idx="1">
+            <a:schemeClr val="accent1"/>
+          </a:fillRef>
+          <a:effectRef idx="0">
+            <a:schemeClr val="accent1"/>
+          </a:effectRef>
+          <a:fontRef idx="minor">
+            <a:schemeClr val="lt1"/>
+          </a:fontRef>
+        </p:style>
+        <p:txBody>
+          <a:bodyPr rtlCol="0" anchor="ctr"/>
+          <a:lstStyle/>
+          <a:p>
+            <a:pPr algn="ctr"/>
+            <a:endParaRPr lang="en-US" dirty="0"/>
+          </a:p>
+        </p:txBody>
+      </p:sp>
+      <p:sp>
+        <p:nvSpPr>
+          <p:cNvPr id="5" name="Flowchart: Manual Operation 4">
+            <a:extLst>
+              <a:ext uri="{FF2B5EF4-FFF2-40B4-BE49-F238E27FC236}">
+                <a16:creationId xmlns:a16="http://schemas.microsoft.com/office/drawing/2014/main" id="{A814C3F0-628E-17AD-1B32-FFA749A89111}"/>
+              </a:ext>
+            </a:extLst>
+          </p:cNvPr>
+          <p:cNvSpPr/>
+          <p:nvPr/>
+        </p:nvSpPr>
+        <p:spPr>
+          <a:xfrm rot="16200000">
+            <a:off x="7339582" y="1777545"/>
+            <a:ext cx="1234440" cy="1536192"/>
+          </a:xfrm>
+          <a:prstGeom prst="flowChartManualOperation">
+            <a:avLst/>
+          </a:prstGeom>
+        </p:spPr>
+        <p:style>
+          <a:lnRef idx="2">
+            <a:schemeClr val="accent1">
+              <a:shade val="15000"/>
+            </a:schemeClr>
+          </a:lnRef>
+          <a:fillRef idx="1">
+            <a:schemeClr val="accent1"/>
+          </a:fillRef>
+          <a:effectRef idx="0">
+            <a:schemeClr val="accent1"/>
+          </a:effectRef>
+          <a:fontRef idx="minor">
+            <a:schemeClr val="lt1"/>
+          </a:fontRef>
+        </p:style>
+        <p:txBody>
+          <a:bodyPr rtlCol="0" anchor="ctr"/>
+          <a:lstStyle/>
+          <a:p>
+            <a:pPr algn="ctr"/>
+            <a:endParaRPr lang="en-US"/>
+          </a:p>
+        </p:txBody>
+      </p:sp>
+      <p:sp>
+        <p:nvSpPr>
+          <p:cNvPr id="6" name="Rectangle 5">
+            <a:extLst>
+              <a:ext uri="{FF2B5EF4-FFF2-40B4-BE49-F238E27FC236}">
+                <a16:creationId xmlns:a16="http://schemas.microsoft.com/office/drawing/2014/main" id="{4876254C-E312-AC3F-296A-8C8089E95C64}"/>
+              </a:ext>
+            </a:extLst>
+          </p:cNvPr>
+          <p:cNvSpPr/>
+          <p:nvPr/>
+        </p:nvSpPr>
+        <p:spPr>
+          <a:xfrm>
+            <a:off x="9214102" y="323649"/>
+            <a:ext cx="612648" cy="813816"/>
+          </a:xfrm>
+          <a:prstGeom prst="rect">
+            <a:avLst/>
+          </a:prstGeom>
+        </p:spPr>
+        <p:style>
+          <a:lnRef idx="2">
+            <a:schemeClr val="accent1">
+              <a:shade val="15000"/>
+            </a:schemeClr>
+          </a:lnRef>
+          <a:fillRef idx="1">
+            <a:schemeClr val="accent1"/>
+          </a:fillRef>
+          <a:effectRef idx="0">
+            <a:schemeClr val="accent1"/>
+          </a:effectRef>
+          <a:fontRef idx="minor">
+            <a:schemeClr val="lt1"/>
+          </a:fontRef>
+        </p:style>
+        <p:txBody>
+          <a:bodyPr rtlCol="0" anchor="ctr"/>
+          <a:lstStyle/>
+          <a:p>
+            <a:pPr algn="ctr"/>
+            <a:r>
+              <a:rPr lang="en-US" sz="1000" dirty="0"/>
+              <a:t>FC Layer</a:t>
+            </a:r>
+          </a:p>
+        </p:txBody>
+      </p:sp>
+      <p:sp>
+        <p:nvSpPr>
+          <p:cNvPr id="7" name="Rectangle 6">
+            <a:extLst>
+              <a:ext uri="{FF2B5EF4-FFF2-40B4-BE49-F238E27FC236}">
+                <a16:creationId xmlns:a16="http://schemas.microsoft.com/office/drawing/2014/main" id="{DB0921E8-B1DC-7906-1981-AC5CAA217799}"/>
+              </a:ext>
+            </a:extLst>
+          </p:cNvPr>
+          <p:cNvSpPr/>
+          <p:nvPr/>
+        </p:nvSpPr>
+        <p:spPr>
+          <a:xfrm>
+            <a:off x="9214102" y="2138733"/>
+            <a:ext cx="612648" cy="813816"/>
+          </a:xfrm>
+          <a:prstGeom prst="rect">
+            <a:avLst/>
+          </a:prstGeom>
+        </p:spPr>
+        <p:style>
+          <a:lnRef idx="2">
+            <a:schemeClr val="accent1">
+              <a:shade val="15000"/>
+            </a:schemeClr>
+          </a:lnRef>
+          <a:fillRef idx="1">
+            <a:schemeClr val="accent1"/>
+          </a:fillRef>
+          <a:effectRef idx="0">
+            <a:schemeClr val="accent1"/>
+          </a:effectRef>
+          <a:fontRef idx="minor">
+            <a:schemeClr val="lt1"/>
+          </a:fontRef>
+        </p:style>
+        <p:txBody>
+          <a:bodyPr rtlCol="0" anchor="ctr"/>
+          <a:lstStyle/>
+          <a:p>
+            <a:pPr algn="ctr"/>
+            <a:r>
+              <a:rPr lang="en-US" sz="1000" dirty="0"/>
+              <a:t>FC Layer</a:t>
+            </a:r>
+          </a:p>
+        </p:txBody>
+      </p:sp>
+      <p:sp>
+        <p:nvSpPr>
+          <p:cNvPr id="8" name="Oval 7">
+            <a:extLst>
+              <a:ext uri="{FF2B5EF4-FFF2-40B4-BE49-F238E27FC236}">
+                <a16:creationId xmlns:a16="http://schemas.microsoft.com/office/drawing/2014/main" id="{2CE971FE-405F-C9D3-8702-CDBF27773B41}"/>
+              </a:ext>
+            </a:extLst>
+          </p:cNvPr>
+          <p:cNvSpPr/>
+          <p:nvPr/>
+        </p:nvSpPr>
+        <p:spPr>
+          <a:xfrm>
+            <a:off x="10453114" y="364797"/>
+            <a:ext cx="813816" cy="731520"/>
+          </a:xfrm>
+          <a:prstGeom prst="ellipse">
+            <a:avLst/>
+          </a:prstGeom>
+        </p:spPr>
+        <p:style>
+          <a:lnRef idx="2">
+            <a:schemeClr val="accent1">
+              <a:shade val="15000"/>
+            </a:schemeClr>
+          </a:lnRef>
+          <a:fillRef idx="1">
+            <a:schemeClr val="accent1"/>
+          </a:fillRef>
+          <a:effectRef idx="0">
+            <a:schemeClr val="accent1"/>
+          </a:effectRef>
+          <a:fontRef idx="minor">
+            <a:schemeClr val="lt1"/>
+          </a:fontRef>
+        </p:style>
+        <p:txBody>
+          <a:bodyPr rtlCol="0" anchor="ctr"/>
+          <a:lstStyle/>
+          <a:p>
+            <a:pPr algn="ctr"/>
+            <a:r>
+              <a:rPr lang="en-US" dirty="0"/>
+              <a:t>0/1</a:t>
+            </a:r>
+          </a:p>
+        </p:txBody>
+      </p:sp>
+      <p:sp>
+        <p:nvSpPr>
+          <p:cNvPr id="9" name="Oval 8">
+            <a:extLst>
+              <a:ext uri="{FF2B5EF4-FFF2-40B4-BE49-F238E27FC236}">
+                <a16:creationId xmlns:a16="http://schemas.microsoft.com/office/drawing/2014/main" id="{7F2CA56D-508E-286B-04AD-B9EBBFC12164}"/>
+              </a:ext>
+            </a:extLst>
+          </p:cNvPr>
+          <p:cNvSpPr/>
+          <p:nvPr/>
+        </p:nvSpPr>
+        <p:spPr>
+          <a:xfrm>
+            <a:off x="10425682" y="2179881"/>
+            <a:ext cx="813816" cy="731520"/>
+          </a:xfrm>
+          <a:prstGeom prst="ellipse">
+            <a:avLst/>
+          </a:prstGeom>
+        </p:spPr>
+        <p:style>
+          <a:lnRef idx="2">
+            <a:schemeClr val="accent1">
+              <a:shade val="15000"/>
+            </a:schemeClr>
+          </a:lnRef>
+          <a:fillRef idx="1">
+            <a:schemeClr val="accent1"/>
+          </a:fillRef>
+          <a:effectRef idx="0">
+            <a:schemeClr val="accent1"/>
+          </a:effectRef>
+          <a:fontRef idx="minor">
+            <a:schemeClr val="lt1"/>
+          </a:fontRef>
+        </p:style>
+        <p:txBody>
+          <a:bodyPr rtlCol="0" anchor="ctr"/>
+          <a:lstStyle/>
+          <a:p>
+            <a:pPr algn="ctr"/>
+            <a:r>
+              <a:rPr lang="en-US" dirty="0"/>
+              <a:t>0/1</a:t>
+            </a:r>
+          </a:p>
+        </p:txBody>
+      </p:sp>
+      <p:pic>
+        <p:nvPicPr>
+          <p:cNvPr id="13" name="Picture 12" descr="An ultrasound of a baby&#10;&#10;AI-generated content may be incorrect.">
+            <a:extLst>
+              <a:ext uri="{FF2B5EF4-FFF2-40B4-BE49-F238E27FC236}">
+                <a16:creationId xmlns:a16="http://schemas.microsoft.com/office/drawing/2014/main" id="{FA1D5242-27AB-4218-9A6C-BFF3197AF615}"/>
+              </a:ext>
+            </a:extLst>
+          </p:cNvPr>
+          <p:cNvPicPr>
+            <a:picLocks noChangeAspect="1"/>
+          </p:cNvPicPr>
+          <p:nvPr/>
+        </p:nvPicPr>
+        <p:blipFill>
+          <a:blip r:embed="rId2">
+            <a:extLst>
+              <a:ext uri="{28A0092B-C50C-407E-A947-70E740481C1C}">
+                <a14:useLocalDpi xmlns:a14="http://schemas.microsoft.com/office/drawing/2010/main" val="0"/>
+              </a:ext>
+            </a:extLst>
+          </a:blip>
+          <a:stretch>
+            <a:fillRect/>
+          </a:stretch>
+        </p:blipFill>
+        <p:spPr>
+          <a:xfrm>
+            <a:off x="5597650" y="269571"/>
+            <a:ext cx="960120" cy="921972"/>
+          </a:xfrm>
+          <a:prstGeom prst="rect">
+            <a:avLst/>
+          </a:prstGeom>
+        </p:spPr>
+      </p:pic>
+      <p:pic>
+        <p:nvPicPr>
+          <p:cNvPr id="14" name="Picture 13" descr="An ultrasound of a baby&#10;&#10;AI-generated content may be incorrect.">
+            <a:extLst>
+              <a:ext uri="{FF2B5EF4-FFF2-40B4-BE49-F238E27FC236}">
+                <a16:creationId xmlns:a16="http://schemas.microsoft.com/office/drawing/2014/main" id="{79095D19-91E9-D0B5-3D78-4E81AAED5D8B}"/>
+              </a:ext>
+            </a:extLst>
+          </p:cNvPr>
+          <p:cNvPicPr>
+            <a:picLocks noChangeAspect="1"/>
+          </p:cNvPicPr>
+          <p:nvPr/>
+        </p:nvPicPr>
+        <p:blipFill>
+          <a:blip r:embed="rId2">
+            <a:extLst>
+              <a:ext uri="{28A0092B-C50C-407E-A947-70E740481C1C}">
+                <a14:useLocalDpi xmlns:a14="http://schemas.microsoft.com/office/drawing/2010/main" val="0"/>
+              </a:ext>
+            </a:extLst>
+          </a:blip>
+          <a:stretch>
+            <a:fillRect/>
+          </a:stretch>
+        </p:blipFill>
+        <p:spPr>
+          <a:xfrm>
+            <a:off x="5597650" y="2084655"/>
+            <a:ext cx="960120" cy="921972"/>
+          </a:xfrm>
+          <a:prstGeom prst="rect">
+            <a:avLst/>
+          </a:prstGeom>
+        </p:spPr>
+      </p:pic>
+      <p:cxnSp>
+        <p:nvCxnSpPr>
+          <p:cNvPr id="16" name="Straight Arrow Connector 15">
+            <a:extLst>
+              <a:ext uri="{FF2B5EF4-FFF2-40B4-BE49-F238E27FC236}">
+                <a16:creationId xmlns:a16="http://schemas.microsoft.com/office/drawing/2014/main" id="{2015EC84-FEFB-0632-D2E7-48EA8DFFB475}"/>
+              </a:ext>
+            </a:extLst>
+          </p:cNvPr>
+          <p:cNvCxnSpPr>
+            <a:stCxn id="13" idx="3"/>
+            <a:endCxn id="4" idx="0"/>
+          </p:cNvCxnSpPr>
+          <p:nvPr/>
+        </p:nvCxnSpPr>
+        <p:spPr>
+          <a:xfrm>
+            <a:off x="6557770" y="730557"/>
+            <a:ext cx="630936" cy="0"/>
+          </a:xfrm>
+          <a:prstGeom prst="straightConnector1">
+            <a:avLst/>
+          </a:prstGeom>
+          <a:ln>
+            <a:tailEnd type="triangle"/>
+          </a:ln>
+        </p:spPr>
+        <p:style>
+          <a:lnRef idx="2">
+            <a:schemeClr val="accent1"/>
+          </a:lnRef>
+          <a:fillRef idx="0">
+            <a:schemeClr val="accent1"/>
+          </a:fillRef>
+          <a:effectRef idx="1">
+            <a:schemeClr val="accent1"/>
+          </a:effectRef>
+          <a:fontRef idx="minor">
+            <a:schemeClr val="tx1"/>
+          </a:fontRef>
+        </p:style>
+      </p:cxnSp>
+      <p:cxnSp>
+        <p:nvCxnSpPr>
+          <p:cNvPr id="19" name="Straight Arrow Connector 18">
+            <a:extLst>
+              <a:ext uri="{FF2B5EF4-FFF2-40B4-BE49-F238E27FC236}">
+                <a16:creationId xmlns:a16="http://schemas.microsoft.com/office/drawing/2014/main" id="{F1D66A19-3357-7A74-CCFA-F827FB4A7AEF}"/>
+              </a:ext>
+            </a:extLst>
+          </p:cNvPr>
+          <p:cNvCxnSpPr>
+            <a:stCxn id="4" idx="2"/>
+            <a:endCxn id="6" idx="1"/>
+          </p:cNvCxnSpPr>
+          <p:nvPr/>
+        </p:nvCxnSpPr>
+        <p:spPr>
+          <a:xfrm>
+            <a:off x="8724898" y="730557"/>
+            <a:ext cx="489204" cy="0"/>
+          </a:xfrm>
+          <a:prstGeom prst="straightConnector1">
+            <a:avLst/>
+          </a:prstGeom>
+          <a:ln>
+            <a:tailEnd type="triangle"/>
+          </a:ln>
+        </p:spPr>
+        <p:style>
+          <a:lnRef idx="2">
+            <a:schemeClr val="accent1"/>
+          </a:lnRef>
+          <a:fillRef idx="0">
+            <a:schemeClr val="accent1"/>
+          </a:fillRef>
+          <a:effectRef idx="1">
+            <a:schemeClr val="accent1"/>
+          </a:effectRef>
+          <a:fontRef idx="minor">
+            <a:schemeClr val="tx1"/>
+          </a:fontRef>
+        </p:style>
+      </p:cxnSp>
+      <p:cxnSp>
+        <p:nvCxnSpPr>
+          <p:cNvPr id="21" name="Straight Arrow Connector 20">
+            <a:extLst>
+              <a:ext uri="{FF2B5EF4-FFF2-40B4-BE49-F238E27FC236}">
+                <a16:creationId xmlns:a16="http://schemas.microsoft.com/office/drawing/2014/main" id="{8A37B851-7F3C-F0E1-8255-27C9574B7CBF}"/>
+              </a:ext>
+            </a:extLst>
+          </p:cNvPr>
+          <p:cNvCxnSpPr>
+            <a:cxnSpLocks/>
+            <a:stCxn id="6" idx="3"/>
+            <a:endCxn id="8" idx="2"/>
+          </p:cNvCxnSpPr>
+          <p:nvPr/>
+        </p:nvCxnSpPr>
+        <p:spPr>
+          <a:xfrm>
+            <a:off x="9826750" y="730557"/>
+            <a:ext cx="626364" cy="0"/>
+          </a:xfrm>
+          <a:prstGeom prst="straightConnector1">
+            <a:avLst/>
+          </a:prstGeom>
+          <a:ln>
+            <a:tailEnd type="triangle"/>
+          </a:ln>
+        </p:spPr>
+        <p:style>
+          <a:lnRef idx="2">
+            <a:schemeClr val="accent1"/>
+          </a:lnRef>
+          <a:fillRef idx="0">
+            <a:schemeClr val="accent1"/>
+          </a:fillRef>
+          <a:effectRef idx="1">
+            <a:schemeClr val="accent1"/>
+          </a:effectRef>
+          <a:fontRef idx="minor">
+            <a:schemeClr val="tx1"/>
+          </a:fontRef>
+        </p:style>
+      </p:cxnSp>
+      <p:cxnSp>
+        <p:nvCxnSpPr>
+          <p:cNvPr id="26" name="Straight Arrow Connector 25">
+            <a:extLst>
+              <a:ext uri="{FF2B5EF4-FFF2-40B4-BE49-F238E27FC236}">
+                <a16:creationId xmlns:a16="http://schemas.microsoft.com/office/drawing/2014/main" id="{A9D287AA-F8CB-0D12-B80E-438ACB6E0B23}"/>
+              </a:ext>
+            </a:extLst>
+          </p:cNvPr>
+          <p:cNvCxnSpPr>
+            <a:cxnSpLocks/>
+            <a:stCxn id="14" idx="3"/>
+            <a:endCxn id="5" idx="0"/>
+          </p:cNvCxnSpPr>
+          <p:nvPr/>
+        </p:nvCxnSpPr>
+        <p:spPr>
+          <a:xfrm>
+            <a:off x="6557770" y="2545641"/>
+            <a:ext cx="630936" cy="0"/>
+          </a:xfrm>
+          <a:prstGeom prst="straightConnector1">
+            <a:avLst/>
+          </a:prstGeom>
+          <a:ln>
+            <a:tailEnd type="triangle"/>
+          </a:ln>
+        </p:spPr>
+        <p:style>
+          <a:lnRef idx="2">
+            <a:schemeClr val="accent1"/>
+          </a:lnRef>
+          <a:fillRef idx="0">
+            <a:schemeClr val="accent1"/>
+          </a:fillRef>
+          <a:effectRef idx="1">
+            <a:schemeClr val="accent1"/>
+          </a:effectRef>
+          <a:fontRef idx="minor">
+            <a:schemeClr val="tx1"/>
+          </a:fontRef>
+        </p:style>
+      </p:cxnSp>
+      <p:cxnSp>
+        <p:nvCxnSpPr>
+          <p:cNvPr id="28" name="Straight Arrow Connector 27">
+            <a:extLst>
+              <a:ext uri="{FF2B5EF4-FFF2-40B4-BE49-F238E27FC236}">
+                <a16:creationId xmlns:a16="http://schemas.microsoft.com/office/drawing/2014/main" id="{EECEE8D3-8437-C6A1-F106-81292148889D}"/>
+              </a:ext>
+            </a:extLst>
+          </p:cNvPr>
+          <p:cNvCxnSpPr>
+            <a:cxnSpLocks/>
+            <a:stCxn id="5" idx="2"/>
+            <a:endCxn id="7" idx="1"/>
+          </p:cNvCxnSpPr>
+          <p:nvPr/>
+        </p:nvCxnSpPr>
+        <p:spPr>
+          <a:xfrm>
+            <a:off x="8724898" y="2545641"/>
+            <a:ext cx="489204" cy="0"/>
+          </a:xfrm>
+          <a:prstGeom prst="straightConnector1">
+            <a:avLst/>
+          </a:prstGeom>
+          <a:ln>
+            <a:tailEnd type="triangle"/>
+          </a:ln>
+        </p:spPr>
+        <p:style>
+          <a:lnRef idx="2">
+            <a:schemeClr val="accent1"/>
+          </a:lnRef>
+          <a:fillRef idx="0">
+            <a:schemeClr val="accent1"/>
+          </a:fillRef>
+          <a:effectRef idx="1">
+            <a:schemeClr val="accent1"/>
+          </a:effectRef>
+          <a:fontRef idx="minor">
+            <a:schemeClr val="tx1"/>
+          </a:fontRef>
+        </p:style>
+      </p:cxnSp>
+      <p:cxnSp>
+        <p:nvCxnSpPr>
+          <p:cNvPr id="30" name="Straight Arrow Connector 29">
+            <a:extLst>
+              <a:ext uri="{FF2B5EF4-FFF2-40B4-BE49-F238E27FC236}">
+                <a16:creationId xmlns:a16="http://schemas.microsoft.com/office/drawing/2014/main" id="{9BD4B4A6-97D0-1848-631B-7907E330EEB3}"/>
+              </a:ext>
+            </a:extLst>
+          </p:cNvPr>
+          <p:cNvCxnSpPr>
+            <a:cxnSpLocks/>
+            <a:stCxn id="7" idx="3"/>
+            <a:endCxn id="9" idx="2"/>
+          </p:cNvCxnSpPr>
+          <p:nvPr/>
+        </p:nvCxnSpPr>
+        <p:spPr>
+          <a:xfrm>
+            <a:off x="9826750" y="2545641"/>
+            <a:ext cx="598932" cy="0"/>
+          </a:xfrm>
+          <a:prstGeom prst="straightConnector1">
+            <a:avLst/>
+          </a:prstGeom>
+          <a:ln>
+            <a:tailEnd type="triangle"/>
+          </a:ln>
+        </p:spPr>
+        <p:style>
+          <a:lnRef idx="2">
+            <a:schemeClr val="accent1"/>
+          </a:lnRef>
+          <a:fillRef idx="0">
+            <a:schemeClr val="accent1"/>
+          </a:fillRef>
+          <a:effectRef idx="1">
+            <a:schemeClr val="accent1"/>
+          </a:effectRef>
+          <a:fontRef idx="minor">
+            <a:schemeClr val="tx1"/>
+          </a:fontRef>
+        </p:style>
+      </p:cxnSp>
+      <p:sp>
+        <p:nvSpPr>
+          <p:cNvPr id="32" name="TextBox 31">
+            <a:extLst>
+              <a:ext uri="{FF2B5EF4-FFF2-40B4-BE49-F238E27FC236}">
+                <a16:creationId xmlns:a16="http://schemas.microsoft.com/office/drawing/2014/main" id="{3F0282A8-E0B0-14FA-CAA4-EBFAD7F6BBC4}"/>
+              </a:ext>
+            </a:extLst>
+          </p:cNvPr>
+          <p:cNvSpPr txBox="1"/>
+          <p:nvPr/>
+        </p:nvSpPr>
+        <p:spPr>
+          <a:xfrm>
+            <a:off x="7312150" y="530502"/>
+            <a:ext cx="1106424" cy="553998"/>
+          </a:xfrm>
+          <a:prstGeom prst="rect">
+            <a:avLst/>
+          </a:prstGeom>
+          <a:noFill/>
+        </p:spPr>
+        <p:txBody>
+          <a:bodyPr wrap="square" rtlCol="0">
+            <a:spAutoFit/>
+          </a:bodyPr>
+          <a:lstStyle/>
+          <a:p>
+            <a:pPr algn="ctr"/>
+            <a:r>
+              <a:rPr lang="en-US" sz="1000" dirty="0">
+                <a:solidFill>
+                  <a:schemeClr val="bg1"/>
+                </a:solidFill>
+              </a:rPr>
+              <a:t>Pretrained Encoder</a:t>
+            </a:r>
+          </a:p>
+          <a:p>
+            <a:pPr algn="ctr"/>
+            <a:r>
+              <a:rPr lang="en-US" sz="1000" dirty="0">
+                <a:solidFill>
+                  <a:schemeClr val="bg1"/>
+                </a:solidFill>
+              </a:rPr>
+              <a:t>(Frozen)</a:t>
+            </a:r>
+          </a:p>
+        </p:txBody>
+      </p:sp>
+      <p:sp>
+        <p:nvSpPr>
+          <p:cNvPr id="34" name="TextBox 33">
+            <a:extLst>
+              <a:ext uri="{FF2B5EF4-FFF2-40B4-BE49-F238E27FC236}">
+                <a16:creationId xmlns:a16="http://schemas.microsoft.com/office/drawing/2014/main" id="{C81A8401-3F72-689E-9168-072034648EDF}"/>
+              </a:ext>
+            </a:extLst>
+          </p:cNvPr>
+          <p:cNvSpPr txBox="1"/>
+          <p:nvPr/>
+        </p:nvSpPr>
+        <p:spPr>
+          <a:xfrm>
+            <a:off x="7364728" y="2345586"/>
+            <a:ext cx="1106424" cy="553998"/>
+          </a:xfrm>
+          <a:prstGeom prst="rect">
+            <a:avLst/>
+          </a:prstGeom>
+          <a:noFill/>
+        </p:spPr>
+        <p:txBody>
+          <a:bodyPr wrap="square" rtlCol="0">
+            <a:spAutoFit/>
+          </a:bodyPr>
+          <a:lstStyle/>
+          <a:p>
+            <a:pPr algn="ctr"/>
+            <a:r>
+              <a:rPr lang="en-US" sz="1000" dirty="0">
+                <a:solidFill>
+                  <a:schemeClr val="bg1"/>
+                </a:solidFill>
+              </a:rPr>
+              <a:t> Encoder</a:t>
+            </a:r>
+          </a:p>
+          <a:p>
+            <a:pPr algn="ctr"/>
+            <a:r>
+              <a:rPr lang="en-US" sz="1000" dirty="0">
+                <a:solidFill>
+                  <a:schemeClr val="bg1"/>
+                </a:solidFill>
+              </a:rPr>
+              <a:t>From Scratch</a:t>
+            </a:r>
+          </a:p>
+          <a:p>
+            <a:pPr algn="ctr"/>
+            <a:r>
+              <a:rPr lang="en-US" sz="1000" dirty="0">
+                <a:solidFill>
+                  <a:schemeClr val="bg1"/>
+                </a:solidFill>
+              </a:rPr>
+              <a:t>(Trainable)</a:t>
+            </a:r>
+          </a:p>
+        </p:txBody>
+      </p:sp>
+      <p:sp>
+        <p:nvSpPr>
+          <p:cNvPr id="10" name="Oval 9">
+            <a:extLst>
+              <a:ext uri="{FF2B5EF4-FFF2-40B4-BE49-F238E27FC236}">
+                <a16:creationId xmlns:a16="http://schemas.microsoft.com/office/drawing/2014/main" id="{01445C38-DA6F-9571-6BB7-A53CFF3F590C}"/>
+              </a:ext>
+            </a:extLst>
+          </p:cNvPr>
+          <p:cNvSpPr/>
+          <p:nvPr/>
+        </p:nvSpPr>
+        <p:spPr>
+          <a:xfrm>
+            <a:off x="11382752" y="3114495"/>
+            <a:ext cx="726948" cy="580644"/>
+          </a:xfrm>
+          <a:prstGeom prst="ellipse">
+            <a:avLst/>
+          </a:prstGeom>
+        </p:spPr>
+        <p:style>
+          <a:lnRef idx="2">
+            <a:schemeClr val="accent1">
+              <a:shade val="15000"/>
+            </a:schemeClr>
+          </a:lnRef>
+          <a:fillRef idx="1">
+            <a:schemeClr val="accent1"/>
+          </a:fillRef>
+          <a:effectRef idx="0">
+            <a:schemeClr val="accent1"/>
+          </a:effectRef>
+          <a:fontRef idx="minor">
+            <a:schemeClr val="lt1"/>
+          </a:fontRef>
+        </p:style>
+        <p:txBody>
+          <a:bodyPr rtlCol="0" anchor="ctr"/>
+          <a:lstStyle/>
+          <a:p>
+            <a:pPr algn="ctr"/>
+            <a:r>
+              <a:rPr lang="en-US" dirty="0"/>
+              <a:t>0/1</a:t>
+            </a:r>
+          </a:p>
+        </p:txBody>
+      </p:sp>
+      <p:cxnSp>
+        <p:nvCxnSpPr>
+          <p:cNvPr id="24" name="Straight Arrow Connector 23">
+            <a:extLst>
+              <a:ext uri="{FF2B5EF4-FFF2-40B4-BE49-F238E27FC236}">
+                <a16:creationId xmlns:a16="http://schemas.microsoft.com/office/drawing/2014/main" id="{8D0393D2-F595-2608-E878-247EADECB2A3}"/>
+              </a:ext>
+            </a:extLst>
+          </p:cNvPr>
+          <p:cNvCxnSpPr>
+            <a:cxnSpLocks/>
+            <a:stCxn id="5" idx="2"/>
+            <a:endCxn id="6" idx="1"/>
+          </p:cNvCxnSpPr>
+          <p:nvPr/>
+        </p:nvCxnSpPr>
+        <p:spPr>
+          <a:xfrm flipV="1">
+            <a:off x="8724898" y="730557"/>
+            <a:ext cx="489204" cy="1815084"/>
+          </a:xfrm>
+          <a:prstGeom prst="straightConnector1">
+            <a:avLst/>
+          </a:prstGeom>
+          <a:ln>
+            <a:tailEnd type="triangle"/>
+          </a:ln>
+        </p:spPr>
+        <p:style>
+          <a:lnRef idx="2">
+            <a:schemeClr val="accent1"/>
+          </a:lnRef>
+          <a:fillRef idx="0">
+            <a:schemeClr val="accent1"/>
+          </a:fillRef>
+          <a:effectRef idx="1">
+            <a:schemeClr val="accent1"/>
+          </a:effectRef>
+          <a:fontRef idx="minor">
+            <a:schemeClr val="tx1"/>
+          </a:fontRef>
+        </p:style>
+      </p:cxnSp>
+      <p:cxnSp>
+        <p:nvCxnSpPr>
+          <p:cNvPr id="27" name="Straight Arrow Connector 26">
+            <a:extLst>
+              <a:ext uri="{FF2B5EF4-FFF2-40B4-BE49-F238E27FC236}">
+                <a16:creationId xmlns:a16="http://schemas.microsoft.com/office/drawing/2014/main" id="{1D1FB2EA-A60D-CD64-FEA4-16796C21C8BD}"/>
+              </a:ext>
+            </a:extLst>
+          </p:cNvPr>
+          <p:cNvCxnSpPr>
+            <a:stCxn id="8" idx="4"/>
+            <a:endCxn id="10" idx="0"/>
+          </p:cNvCxnSpPr>
+          <p:nvPr/>
+        </p:nvCxnSpPr>
+        <p:spPr>
+          <a:xfrm>
+            <a:off x="10860022" y="1096317"/>
+            <a:ext cx="886204" cy="2018178"/>
+          </a:xfrm>
+          <a:prstGeom prst="straightConnector1">
+            <a:avLst/>
+          </a:prstGeom>
+          <a:ln>
+            <a:tailEnd type="triangle"/>
+          </a:ln>
+        </p:spPr>
+        <p:style>
+          <a:lnRef idx="2">
+            <a:schemeClr val="accent1"/>
+          </a:lnRef>
+          <a:fillRef idx="0">
+            <a:schemeClr val="accent1"/>
+          </a:fillRef>
+          <a:effectRef idx="1">
+            <a:schemeClr val="accent1"/>
+          </a:effectRef>
+          <a:fontRef idx="minor">
+            <a:schemeClr val="tx1"/>
+          </a:fontRef>
+        </p:style>
+      </p:cxnSp>
+      <p:cxnSp>
+        <p:nvCxnSpPr>
+          <p:cNvPr id="35" name="Straight Arrow Connector 34">
+            <a:extLst>
+              <a:ext uri="{FF2B5EF4-FFF2-40B4-BE49-F238E27FC236}">
+                <a16:creationId xmlns:a16="http://schemas.microsoft.com/office/drawing/2014/main" id="{51A129CE-FC9F-12F3-572F-A79E3040230C}"/>
+              </a:ext>
+            </a:extLst>
+          </p:cNvPr>
+          <p:cNvCxnSpPr>
+            <a:cxnSpLocks/>
+            <a:stCxn id="9" idx="0"/>
+            <a:endCxn id="10" idx="4"/>
+          </p:cNvCxnSpPr>
+          <p:nvPr/>
+        </p:nvCxnSpPr>
+        <p:spPr>
+          <a:xfrm>
+            <a:off x="10832590" y="2179881"/>
+            <a:ext cx="913636" cy="1515258"/>
+          </a:xfrm>
+          <a:prstGeom prst="straightConnector1">
+            <a:avLst/>
+          </a:prstGeom>
+          <a:ln>
+            <a:tailEnd type="triangle"/>
+          </a:ln>
+        </p:spPr>
+        <p:style>
+          <a:lnRef idx="2">
+            <a:schemeClr val="accent1"/>
+          </a:lnRef>
+          <a:fillRef idx="0">
+            <a:schemeClr val="accent1"/>
+          </a:fillRef>
+          <a:effectRef idx="1">
+            <a:schemeClr val="accent1"/>
+          </a:effectRef>
+          <a:fontRef idx="minor">
+            <a:schemeClr val="tx1"/>
+          </a:fontRef>
+        </p:style>
+      </p:cxnSp>
+      <p:sp>
+        <p:nvSpPr>
+          <p:cNvPr id="17" name="Flowchart: Manual Operation 16">
+            <a:extLst>
+              <a:ext uri="{FF2B5EF4-FFF2-40B4-BE49-F238E27FC236}">
+                <a16:creationId xmlns:a16="http://schemas.microsoft.com/office/drawing/2014/main" id="{92E51D39-F684-B440-37A1-846999A51CB4}"/>
+              </a:ext>
+            </a:extLst>
+          </p:cNvPr>
+          <p:cNvSpPr/>
+          <p:nvPr/>
+        </p:nvSpPr>
+        <p:spPr>
+          <a:xfrm rot="16200000">
+            <a:off x="7339582" y="5149035"/>
+            <a:ext cx="1234440" cy="1536192"/>
+          </a:xfrm>
+          <a:prstGeom prst="flowChartManualOperation">
+            <a:avLst/>
+          </a:prstGeom>
+        </p:spPr>
+        <p:style>
+          <a:lnRef idx="2">
+            <a:schemeClr val="accent1">
+              <a:shade val="15000"/>
+            </a:schemeClr>
+          </a:lnRef>
+          <a:fillRef idx="1">
+            <a:schemeClr val="accent1"/>
+          </a:fillRef>
+          <a:effectRef idx="0">
+            <a:schemeClr val="accent1"/>
+          </a:effectRef>
+          <a:fontRef idx="minor">
+            <a:schemeClr val="lt1"/>
+          </a:fontRef>
+        </p:style>
+        <p:txBody>
+          <a:bodyPr rtlCol="0" anchor="ctr"/>
+          <a:lstStyle/>
+          <a:p>
+            <a:pPr algn="ctr"/>
+            <a:endParaRPr lang="en-US"/>
+          </a:p>
+        </p:txBody>
+      </p:sp>
+      <p:sp>
+        <p:nvSpPr>
+          <p:cNvPr id="18" name="Rectangle 17">
+            <a:extLst>
+              <a:ext uri="{FF2B5EF4-FFF2-40B4-BE49-F238E27FC236}">
+                <a16:creationId xmlns:a16="http://schemas.microsoft.com/office/drawing/2014/main" id="{958FDEE7-42BD-A4A3-3E87-5C4583D847CB}"/>
+              </a:ext>
+            </a:extLst>
+          </p:cNvPr>
+          <p:cNvSpPr/>
+          <p:nvPr/>
+        </p:nvSpPr>
+        <p:spPr>
+          <a:xfrm>
+            <a:off x="9214102" y="3695139"/>
+            <a:ext cx="612648" cy="813816"/>
+          </a:xfrm>
+          <a:prstGeom prst="rect">
+            <a:avLst/>
+          </a:prstGeom>
+        </p:spPr>
+        <p:style>
+          <a:lnRef idx="2">
+            <a:schemeClr val="accent1">
+              <a:shade val="15000"/>
+            </a:schemeClr>
+          </a:lnRef>
+          <a:fillRef idx="1">
+            <a:schemeClr val="accent1"/>
+          </a:fillRef>
+          <a:effectRef idx="0">
+            <a:schemeClr val="accent1"/>
+          </a:effectRef>
+          <a:fontRef idx="minor">
+            <a:schemeClr val="lt1"/>
+          </a:fontRef>
+        </p:style>
+        <p:txBody>
+          <a:bodyPr rtlCol="0" anchor="ctr"/>
+          <a:lstStyle/>
+          <a:p>
+            <a:pPr algn="ctr"/>
+            <a:r>
+              <a:rPr lang="en-US" sz="1000" dirty="0"/>
+              <a:t>FC Layer</a:t>
+            </a:r>
+          </a:p>
+        </p:txBody>
+      </p:sp>
+      <p:sp>
+        <p:nvSpPr>
+          <p:cNvPr id="20" name="Rectangle 19">
+            <a:extLst>
+              <a:ext uri="{FF2B5EF4-FFF2-40B4-BE49-F238E27FC236}">
+                <a16:creationId xmlns:a16="http://schemas.microsoft.com/office/drawing/2014/main" id="{EFF97933-D75D-3B27-F90A-9BBD101775BD}"/>
+              </a:ext>
+            </a:extLst>
+          </p:cNvPr>
+          <p:cNvSpPr/>
+          <p:nvPr/>
+        </p:nvSpPr>
+        <p:spPr>
+          <a:xfrm>
+            <a:off x="9214102" y="5510223"/>
+            <a:ext cx="612648" cy="813816"/>
+          </a:xfrm>
+          <a:prstGeom prst="rect">
+            <a:avLst/>
+          </a:prstGeom>
+        </p:spPr>
+        <p:style>
+          <a:lnRef idx="2">
+            <a:schemeClr val="accent1">
+              <a:shade val="15000"/>
+            </a:schemeClr>
+          </a:lnRef>
+          <a:fillRef idx="1">
+            <a:schemeClr val="accent1"/>
+          </a:fillRef>
+          <a:effectRef idx="0">
+            <a:schemeClr val="accent1"/>
+          </a:effectRef>
+          <a:fontRef idx="minor">
+            <a:schemeClr val="lt1"/>
+          </a:fontRef>
+        </p:style>
+        <p:txBody>
+          <a:bodyPr rtlCol="0" anchor="ctr"/>
+          <a:lstStyle/>
+          <a:p>
+            <a:pPr algn="ctr"/>
+            <a:r>
+              <a:rPr lang="en-US" sz="1000" dirty="0"/>
+              <a:t>FC Layer</a:t>
+            </a:r>
+          </a:p>
+        </p:txBody>
+      </p:sp>
+      <p:sp>
+        <p:nvSpPr>
+          <p:cNvPr id="23" name="Oval 22">
+            <a:extLst>
+              <a:ext uri="{FF2B5EF4-FFF2-40B4-BE49-F238E27FC236}">
+                <a16:creationId xmlns:a16="http://schemas.microsoft.com/office/drawing/2014/main" id="{71A575BD-BCC9-9BB5-6083-1D4594ED80CF}"/>
+              </a:ext>
+            </a:extLst>
+          </p:cNvPr>
+          <p:cNvSpPr/>
+          <p:nvPr/>
+        </p:nvSpPr>
+        <p:spPr>
+          <a:xfrm>
+            <a:off x="10453114" y="3736287"/>
+            <a:ext cx="813816" cy="731520"/>
+          </a:xfrm>
+          <a:prstGeom prst="ellipse">
+            <a:avLst/>
+          </a:prstGeom>
+        </p:spPr>
+        <p:style>
+          <a:lnRef idx="2">
+            <a:schemeClr val="accent1">
+              <a:shade val="15000"/>
+            </a:schemeClr>
+          </a:lnRef>
+          <a:fillRef idx="1">
+            <a:schemeClr val="accent1"/>
+          </a:fillRef>
+          <a:effectRef idx="0">
+            <a:schemeClr val="accent1"/>
+          </a:effectRef>
+          <a:fontRef idx="minor">
+            <a:schemeClr val="lt1"/>
+          </a:fontRef>
+        </p:style>
+        <p:txBody>
+          <a:bodyPr rtlCol="0" anchor="ctr"/>
+          <a:lstStyle/>
+          <a:p>
+            <a:pPr algn="ctr"/>
+            <a:r>
+              <a:rPr lang="en-US" dirty="0"/>
+              <a:t>0/1</a:t>
+            </a:r>
+          </a:p>
+        </p:txBody>
+      </p:sp>
+      <p:sp>
+        <p:nvSpPr>
+          <p:cNvPr id="25" name="Oval 24">
+            <a:extLst>
+              <a:ext uri="{FF2B5EF4-FFF2-40B4-BE49-F238E27FC236}">
+                <a16:creationId xmlns:a16="http://schemas.microsoft.com/office/drawing/2014/main" id="{CB4FFA83-4F62-82D7-170C-F5BCC7332F28}"/>
+              </a:ext>
+            </a:extLst>
+          </p:cNvPr>
+          <p:cNvSpPr/>
+          <p:nvPr/>
+        </p:nvSpPr>
+        <p:spPr>
+          <a:xfrm>
+            <a:off x="10425682" y="5551371"/>
+            <a:ext cx="813816" cy="731520"/>
+          </a:xfrm>
+          <a:prstGeom prst="ellipse">
+            <a:avLst/>
+          </a:prstGeom>
+        </p:spPr>
+        <p:style>
+          <a:lnRef idx="2">
+            <a:schemeClr val="accent1">
+              <a:shade val="15000"/>
+            </a:schemeClr>
+          </a:lnRef>
+          <a:fillRef idx="1">
+            <a:schemeClr val="accent1"/>
+          </a:fillRef>
+          <a:effectRef idx="0">
+            <a:schemeClr val="accent1"/>
+          </a:effectRef>
+          <a:fontRef idx="minor">
+            <a:schemeClr val="lt1"/>
+          </a:fontRef>
+        </p:style>
+        <p:txBody>
+          <a:bodyPr rtlCol="0" anchor="ctr"/>
+          <a:lstStyle/>
+          <a:p>
+            <a:pPr algn="ctr"/>
+            <a:r>
+              <a:rPr lang="en-US" dirty="0"/>
+              <a:t>0/1</a:t>
+            </a:r>
+          </a:p>
+        </p:txBody>
+      </p:sp>
+      <p:pic>
+        <p:nvPicPr>
+          <p:cNvPr id="29" name="Picture 28" descr="An ultrasound of a baby&#10;&#10;AI-generated content may be incorrect.">
+            <a:extLst>
+              <a:ext uri="{FF2B5EF4-FFF2-40B4-BE49-F238E27FC236}">
+                <a16:creationId xmlns:a16="http://schemas.microsoft.com/office/drawing/2014/main" id="{49D27790-A509-CFF5-D79D-C4D2817CD610}"/>
+              </a:ext>
+            </a:extLst>
+          </p:cNvPr>
+          <p:cNvPicPr>
+            <a:picLocks noChangeAspect="1"/>
+          </p:cNvPicPr>
+          <p:nvPr/>
+        </p:nvPicPr>
+        <p:blipFill>
+          <a:blip r:embed="rId2">
+            <a:extLst>
+              <a:ext uri="{28A0092B-C50C-407E-A947-70E740481C1C}">
+                <a14:useLocalDpi xmlns:a14="http://schemas.microsoft.com/office/drawing/2010/main" val="0"/>
+              </a:ext>
+            </a:extLst>
+          </a:blip>
+          <a:stretch>
+            <a:fillRect/>
+          </a:stretch>
+        </p:blipFill>
+        <p:spPr>
+          <a:xfrm>
+            <a:off x="5597650" y="3641061"/>
+            <a:ext cx="960120" cy="921972"/>
+          </a:xfrm>
+          <a:prstGeom prst="rect">
+            <a:avLst/>
+          </a:prstGeom>
+        </p:spPr>
+      </p:pic>
+      <p:pic>
+        <p:nvPicPr>
+          <p:cNvPr id="31" name="Picture 30" descr="An ultrasound of a baby&#10;&#10;AI-generated content may be incorrect.">
+            <a:extLst>
+              <a:ext uri="{FF2B5EF4-FFF2-40B4-BE49-F238E27FC236}">
+                <a16:creationId xmlns:a16="http://schemas.microsoft.com/office/drawing/2014/main" id="{77A1AF02-EEDB-F412-5B68-93B4036970FF}"/>
+              </a:ext>
+            </a:extLst>
+          </p:cNvPr>
+          <p:cNvPicPr>
+            <a:picLocks noChangeAspect="1"/>
+          </p:cNvPicPr>
+          <p:nvPr/>
+        </p:nvPicPr>
+        <p:blipFill>
+          <a:blip r:embed="rId2">
+            <a:extLst>
+              <a:ext uri="{28A0092B-C50C-407E-A947-70E740481C1C}">
+                <a14:useLocalDpi xmlns:a14="http://schemas.microsoft.com/office/drawing/2010/main" val="0"/>
+              </a:ext>
+            </a:extLst>
+          </a:blip>
+          <a:stretch>
+            <a:fillRect/>
+          </a:stretch>
+        </p:blipFill>
+        <p:spPr>
+          <a:xfrm>
+            <a:off x="5597650" y="5456145"/>
+            <a:ext cx="960120" cy="921972"/>
+          </a:xfrm>
+          <a:prstGeom prst="rect">
+            <a:avLst/>
+          </a:prstGeom>
+        </p:spPr>
+      </p:pic>
+      <p:cxnSp>
+        <p:nvCxnSpPr>
+          <p:cNvPr id="33" name="Straight Arrow Connector 32">
+            <a:extLst>
+              <a:ext uri="{FF2B5EF4-FFF2-40B4-BE49-F238E27FC236}">
+                <a16:creationId xmlns:a16="http://schemas.microsoft.com/office/drawing/2014/main" id="{F826E3D3-521D-4075-FB34-AE3A62F57AF2}"/>
+              </a:ext>
+            </a:extLst>
+          </p:cNvPr>
+          <p:cNvCxnSpPr>
+            <a:stCxn id="29" idx="3"/>
+          </p:cNvCxnSpPr>
+          <p:nvPr/>
+        </p:nvCxnSpPr>
+        <p:spPr>
+          <a:xfrm>
+            <a:off x="6557770" y="4102047"/>
+            <a:ext cx="630936" cy="0"/>
+          </a:xfrm>
+          <a:prstGeom prst="straightConnector1">
+            <a:avLst/>
+          </a:prstGeom>
+          <a:ln>
+            <a:tailEnd type="triangle"/>
+          </a:ln>
+        </p:spPr>
+        <p:style>
+          <a:lnRef idx="2">
+            <a:schemeClr val="accent1"/>
+          </a:lnRef>
+          <a:fillRef idx="0">
+            <a:schemeClr val="accent1"/>
+          </a:fillRef>
+          <a:effectRef idx="1">
+            <a:schemeClr val="accent1"/>
+          </a:effectRef>
+          <a:fontRef idx="minor">
+            <a:schemeClr val="tx1"/>
+          </a:fontRef>
+        </p:style>
+      </p:cxnSp>
+      <p:cxnSp>
+        <p:nvCxnSpPr>
+          <p:cNvPr id="36" name="Straight Arrow Connector 35">
+            <a:extLst>
+              <a:ext uri="{FF2B5EF4-FFF2-40B4-BE49-F238E27FC236}">
+                <a16:creationId xmlns:a16="http://schemas.microsoft.com/office/drawing/2014/main" id="{B7D9C5D0-1259-60AC-DE91-15963CBC8E9E}"/>
+              </a:ext>
+            </a:extLst>
+          </p:cNvPr>
+          <p:cNvCxnSpPr>
+            <a:endCxn id="18" idx="1"/>
+          </p:cNvCxnSpPr>
+          <p:nvPr/>
+        </p:nvCxnSpPr>
+        <p:spPr>
+          <a:xfrm>
+            <a:off x="8724898" y="4102047"/>
+            <a:ext cx="489204" cy="0"/>
+          </a:xfrm>
+          <a:prstGeom prst="straightConnector1">
+            <a:avLst/>
+          </a:prstGeom>
+          <a:ln>
+            <a:tailEnd type="triangle"/>
+          </a:ln>
+        </p:spPr>
+        <p:style>
+          <a:lnRef idx="2">
+            <a:schemeClr val="accent1"/>
+          </a:lnRef>
+          <a:fillRef idx="0">
+            <a:schemeClr val="accent1"/>
+          </a:fillRef>
+          <a:effectRef idx="1">
+            <a:schemeClr val="accent1"/>
+          </a:effectRef>
+          <a:fontRef idx="minor">
+            <a:schemeClr val="tx1"/>
+          </a:fontRef>
+        </p:style>
+      </p:cxnSp>
+      <p:cxnSp>
+        <p:nvCxnSpPr>
+          <p:cNvPr id="37" name="Straight Arrow Connector 36">
+            <a:extLst>
+              <a:ext uri="{FF2B5EF4-FFF2-40B4-BE49-F238E27FC236}">
+                <a16:creationId xmlns:a16="http://schemas.microsoft.com/office/drawing/2014/main" id="{A31475FF-BCFA-28E3-8C93-ED97883F9115}"/>
+              </a:ext>
+            </a:extLst>
+          </p:cNvPr>
+          <p:cNvCxnSpPr>
+            <a:cxnSpLocks/>
+            <a:stCxn id="18" idx="3"/>
+            <a:endCxn id="23" idx="2"/>
+          </p:cNvCxnSpPr>
+          <p:nvPr/>
+        </p:nvCxnSpPr>
+        <p:spPr>
+          <a:xfrm>
+            <a:off x="9826750" y="4102047"/>
+            <a:ext cx="626364" cy="0"/>
+          </a:xfrm>
+          <a:prstGeom prst="straightConnector1">
+            <a:avLst/>
+          </a:prstGeom>
+          <a:ln>
+            <a:tailEnd type="triangle"/>
+          </a:ln>
+        </p:spPr>
+        <p:style>
+          <a:lnRef idx="2">
+            <a:schemeClr val="accent1"/>
+          </a:lnRef>
+          <a:fillRef idx="0">
+            <a:schemeClr val="accent1"/>
+          </a:fillRef>
+          <a:effectRef idx="1">
+            <a:schemeClr val="accent1"/>
+          </a:effectRef>
+          <a:fontRef idx="minor">
+            <a:schemeClr val="tx1"/>
+          </a:fontRef>
+        </p:style>
+      </p:cxnSp>
+      <p:cxnSp>
+        <p:nvCxnSpPr>
+          <p:cNvPr id="38" name="Straight Arrow Connector 37">
+            <a:extLst>
+              <a:ext uri="{FF2B5EF4-FFF2-40B4-BE49-F238E27FC236}">
+                <a16:creationId xmlns:a16="http://schemas.microsoft.com/office/drawing/2014/main" id="{80549D5B-A956-C882-F9AC-4B0FC91C48FA}"/>
+              </a:ext>
+            </a:extLst>
+          </p:cNvPr>
+          <p:cNvCxnSpPr>
+            <a:cxnSpLocks/>
+            <a:stCxn id="31" idx="3"/>
+            <a:endCxn id="17" idx="0"/>
+          </p:cNvCxnSpPr>
+          <p:nvPr/>
+        </p:nvCxnSpPr>
+        <p:spPr>
+          <a:xfrm>
+            <a:off x="6557770" y="5917131"/>
+            <a:ext cx="630936" cy="0"/>
+          </a:xfrm>
+          <a:prstGeom prst="straightConnector1">
+            <a:avLst/>
+          </a:prstGeom>
+          <a:ln>
+            <a:tailEnd type="triangle"/>
+          </a:ln>
+        </p:spPr>
+        <p:style>
+          <a:lnRef idx="2">
+            <a:schemeClr val="accent1"/>
+          </a:lnRef>
+          <a:fillRef idx="0">
+            <a:schemeClr val="accent1"/>
+          </a:fillRef>
+          <a:effectRef idx="1">
+            <a:schemeClr val="accent1"/>
+          </a:effectRef>
+          <a:fontRef idx="minor">
+            <a:schemeClr val="tx1"/>
+          </a:fontRef>
+        </p:style>
+      </p:cxnSp>
+      <p:cxnSp>
+        <p:nvCxnSpPr>
+          <p:cNvPr id="39" name="Straight Arrow Connector 38">
+            <a:extLst>
+              <a:ext uri="{FF2B5EF4-FFF2-40B4-BE49-F238E27FC236}">
+                <a16:creationId xmlns:a16="http://schemas.microsoft.com/office/drawing/2014/main" id="{BFEC9395-C218-871E-088E-18318EAC809D}"/>
+              </a:ext>
+            </a:extLst>
+          </p:cNvPr>
+          <p:cNvCxnSpPr>
+            <a:cxnSpLocks/>
+            <a:stCxn id="17" idx="2"/>
+            <a:endCxn id="20" idx="1"/>
+          </p:cNvCxnSpPr>
+          <p:nvPr/>
+        </p:nvCxnSpPr>
+        <p:spPr>
+          <a:xfrm>
+            <a:off x="8724898" y="5917131"/>
+            <a:ext cx="489204" cy="0"/>
+          </a:xfrm>
+          <a:prstGeom prst="straightConnector1">
+            <a:avLst/>
+          </a:prstGeom>
+          <a:ln>
+            <a:tailEnd type="triangle"/>
+          </a:ln>
+        </p:spPr>
+        <p:style>
+          <a:lnRef idx="2">
+            <a:schemeClr val="accent1"/>
+          </a:lnRef>
+          <a:fillRef idx="0">
+            <a:schemeClr val="accent1"/>
+          </a:fillRef>
+          <a:effectRef idx="1">
+            <a:schemeClr val="accent1"/>
+          </a:effectRef>
+          <a:fontRef idx="minor">
+            <a:schemeClr val="tx1"/>
+          </a:fontRef>
+        </p:style>
+      </p:cxnSp>
+      <p:cxnSp>
+        <p:nvCxnSpPr>
+          <p:cNvPr id="40" name="Straight Arrow Connector 39">
+            <a:extLst>
+              <a:ext uri="{FF2B5EF4-FFF2-40B4-BE49-F238E27FC236}">
+                <a16:creationId xmlns:a16="http://schemas.microsoft.com/office/drawing/2014/main" id="{4F799523-84B7-2DCE-A2E1-CB9C7159E750}"/>
+              </a:ext>
+            </a:extLst>
+          </p:cNvPr>
+          <p:cNvCxnSpPr>
+            <a:cxnSpLocks/>
+            <a:stCxn id="20" idx="3"/>
+            <a:endCxn id="25" idx="2"/>
+          </p:cNvCxnSpPr>
+          <p:nvPr/>
+        </p:nvCxnSpPr>
+        <p:spPr>
+          <a:xfrm>
+            <a:off x="9826750" y="5917131"/>
+            <a:ext cx="598932" cy="0"/>
+          </a:xfrm>
+          <a:prstGeom prst="straightConnector1">
+            <a:avLst/>
+          </a:prstGeom>
+          <a:ln>
+            <a:tailEnd type="triangle"/>
+          </a:ln>
+        </p:spPr>
+        <p:style>
+          <a:lnRef idx="2">
+            <a:schemeClr val="accent1"/>
+          </a:lnRef>
+          <a:fillRef idx="0">
+            <a:schemeClr val="accent1"/>
+          </a:fillRef>
+          <a:effectRef idx="1">
+            <a:schemeClr val="accent1"/>
+          </a:effectRef>
+          <a:fontRef idx="minor">
+            <a:schemeClr val="tx1"/>
+          </a:fontRef>
+        </p:style>
+      </p:cxnSp>
+      <p:sp>
+        <p:nvSpPr>
+          <p:cNvPr id="41" name="TextBox 40">
+            <a:extLst>
+              <a:ext uri="{FF2B5EF4-FFF2-40B4-BE49-F238E27FC236}">
+                <a16:creationId xmlns:a16="http://schemas.microsoft.com/office/drawing/2014/main" id="{84EA2F37-CB52-088E-3C8B-846513651030}"/>
+              </a:ext>
+            </a:extLst>
+          </p:cNvPr>
+          <p:cNvSpPr txBox="1"/>
+          <p:nvPr/>
+        </p:nvSpPr>
+        <p:spPr>
+          <a:xfrm>
+            <a:off x="7061640" y="3674767"/>
+            <a:ext cx="1500759" cy="1015663"/>
+          </a:xfrm>
+          <a:prstGeom prst="rect">
+            <a:avLst/>
+          </a:prstGeom>
+          <a:noFill/>
+        </p:spPr>
+        <p:txBody>
+          <a:bodyPr wrap="square" rtlCol="0">
+            <a:spAutoFit/>
+          </a:bodyPr>
+          <a:lstStyle/>
+          <a:p>
+            <a:pPr algn="ctr"/>
+            <a:r>
+              <a:rPr lang="en-US" sz="1000" dirty="0">
+                <a:solidFill>
+                  <a:schemeClr val="bg1"/>
+                </a:solidFill>
+              </a:rPr>
+              <a:t>1. SDF-Model -&gt;</a:t>
+            </a:r>
+          </a:p>
+          <a:p>
+            <a:pPr marL="171450" indent="-171450" algn="ctr">
+              <a:buFont typeface="Wingdings" panose="05000000000000000000" pitchFamily="2" charset="2"/>
+              <a:buChar char="è"/>
+            </a:pPr>
+            <a:r>
+              <a:rPr lang="en-US" sz="1000" dirty="0">
+                <a:solidFill>
+                  <a:schemeClr val="bg1"/>
+                </a:solidFill>
+              </a:rPr>
+              <a:t>2 .Binary Boundary Mask-&gt;</a:t>
+            </a:r>
+          </a:p>
+          <a:p>
+            <a:pPr marL="171450" indent="-171450" algn="ctr">
+              <a:buFont typeface="Wingdings" panose="05000000000000000000" pitchFamily="2" charset="2"/>
+              <a:buChar char="è"/>
+            </a:pPr>
+            <a:r>
+              <a:rPr lang="en-US" sz="1000" dirty="0">
+                <a:solidFill>
+                  <a:schemeClr val="bg1"/>
+                </a:solidFill>
+              </a:rPr>
+              <a:t>3. US image within Boundary-&gt;</a:t>
+            </a:r>
+          </a:p>
+          <a:p>
+            <a:pPr marL="171450" indent="-171450" algn="ctr">
+              <a:buFont typeface="Wingdings" panose="05000000000000000000" pitchFamily="2" charset="2"/>
+              <a:buChar char="è"/>
+            </a:pPr>
+            <a:r>
+              <a:rPr lang="en-US" sz="1000" dirty="0">
+                <a:solidFill>
+                  <a:schemeClr val="bg1"/>
+                </a:solidFill>
+              </a:rPr>
+              <a:t>4. Encoder</a:t>
+            </a:r>
+          </a:p>
+        </p:txBody>
+      </p:sp>
+      <p:cxnSp>
+        <p:nvCxnSpPr>
+          <p:cNvPr id="46" name="Straight Arrow Connector 45">
+            <a:extLst>
+              <a:ext uri="{FF2B5EF4-FFF2-40B4-BE49-F238E27FC236}">
+                <a16:creationId xmlns:a16="http://schemas.microsoft.com/office/drawing/2014/main" id="{696EFC68-D78F-6891-9F33-5389F0FFC42E}"/>
+              </a:ext>
+            </a:extLst>
+          </p:cNvPr>
+          <p:cNvCxnSpPr>
+            <a:cxnSpLocks/>
+            <a:stCxn id="25" idx="0"/>
+          </p:cNvCxnSpPr>
+          <p:nvPr/>
+        </p:nvCxnSpPr>
+        <p:spPr>
+          <a:xfrm flipV="1">
+            <a:off x="10832590" y="3695139"/>
+            <a:ext cx="941068" cy="1856232"/>
+          </a:xfrm>
+          <a:prstGeom prst="straightConnector1">
+            <a:avLst/>
+          </a:prstGeom>
+          <a:ln>
+            <a:tailEnd type="triangle"/>
+          </a:ln>
+        </p:spPr>
+        <p:style>
+          <a:lnRef idx="2">
+            <a:schemeClr val="accent1"/>
+          </a:lnRef>
+          <a:fillRef idx="0">
+            <a:schemeClr val="accent1"/>
+          </a:fillRef>
+          <a:effectRef idx="1">
+            <a:schemeClr val="accent1"/>
+          </a:effectRef>
+          <a:fontRef idx="minor">
+            <a:schemeClr val="tx1"/>
+          </a:fontRef>
+        </p:style>
+      </p:cxnSp>
+      <p:sp>
+        <p:nvSpPr>
+          <p:cNvPr id="56" name="TextBox 55">
+            <a:extLst>
+              <a:ext uri="{FF2B5EF4-FFF2-40B4-BE49-F238E27FC236}">
+                <a16:creationId xmlns:a16="http://schemas.microsoft.com/office/drawing/2014/main" id="{E312B1C2-0408-2A37-3531-2D469F022E23}"/>
+              </a:ext>
+            </a:extLst>
+          </p:cNvPr>
+          <p:cNvSpPr txBox="1"/>
+          <p:nvPr/>
+        </p:nvSpPr>
+        <p:spPr>
+          <a:xfrm>
+            <a:off x="7061639" y="5405504"/>
+            <a:ext cx="1500759" cy="1015663"/>
+          </a:xfrm>
+          <a:prstGeom prst="rect">
+            <a:avLst/>
+          </a:prstGeom>
+          <a:noFill/>
+        </p:spPr>
+        <p:txBody>
+          <a:bodyPr wrap="square" rtlCol="0">
+            <a:spAutoFit/>
+          </a:bodyPr>
+          <a:lstStyle/>
+          <a:p>
+            <a:pPr algn="ctr"/>
+            <a:r>
+              <a:rPr lang="en-US" sz="1000" dirty="0">
+                <a:solidFill>
+                  <a:schemeClr val="bg1"/>
+                </a:solidFill>
+              </a:rPr>
+              <a:t>1. SDF-Model -&gt;</a:t>
+            </a:r>
+          </a:p>
+          <a:p>
+            <a:pPr marL="171450" indent="-171450" algn="ctr">
+              <a:buFont typeface="Wingdings" panose="05000000000000000000" pitchFamily="2" charset="2"/>
+              <a:buChar char="è"/>
+            </a:pPr>
+            <a:r>
+              <a:rPr lang="en-US" sz="1000" dirty="0">
+                <a:solidFill>
+                  <a:schemeClr val="bg1"/>
+                </a:solidFill>
+              </a:rPr>
+              <a:t>2 . Lesion Centre Mask-&gt;</a:t>
+            </a:r>
+          </a:p>
+          <a:p>
+            <a:pPr marL="171450" indent="-171450" algn="ctr">
+              <a:buFont typeface="Wingdings" panose="05000000000000000000" pitchFamily="2" charset="2"/>
+              <a:buChar char="è"/>
+            </a:pPr>
+            <a:r>
+              <a:rPr lang="en-US" sz="1000" dirty="0">
+                <a:solidFill>
+                  <a:schemeClr val="bg1"/>
+                </a:solidFill>
+              </a:rPr>
+              <a:t>3. US image within Lesion Center-&gt;</a:t>
+            </a:r>
+          </a:p>
+          <a:p>
+            <a:pPr marL="171450" indent="-171450" algn="ctr">
+              <a:buFont typeface="Wingdings" panose="05000000000000000000" pitchFamily="2" charset="2"/>
+              <a:buChar char="è"/>
+            </a:pPr>
+            <a:r>
+              <a:rPr lang="en-US" sz="1000" dirty="0">
+                <a:solidFill>
+                  <a:schemeClr val="bg1"/>
+                </a:solidFill>
+              </a:rPr>
+              <a:t>4. Encoder</a:t>
+            </a:r>
+          </a:p>
+        </p:txBody>
+      </p:sp>
+      <p:pic>
+        <p:nvPicPr>
+          <p:cNvPr id="42" name="Picture 41" descr="A graph of a curve&#10;&#10;AI-generated content may be incorrect.">
+            <a:extLst>
+              <a:ext uri="{FF2B5EF4-FFF2-40B4-BE49-F238E27FC236}">
+                <a16:creationId xmlns:a16="http://schemas.microsoft.com/office/drawing/2014/main" id="{1625C777-DF7E-8CD0-2FDA-DF78022A72E2}"/>
+              </a:ext>
+            </a:extLst>
+          </p:cNvPr>
+          <p:cNvPicPr>
+            <a:picLocks noChangeAspect="1"/>
+          </p:cNvPicPr>
+          <p:nvPr/>
+        </p:nvPicPr>
+        <p:blipFill>
+          <a:blip r:embed="rId3">
+            <a:extLst>
+              <a:ext uri="{28A0092B-C50C-407E-A947-70E740481C1C}">
+                <a14:useLocalDpi xmlns:a14="http://schemas.microsoft.com/office/drawing/2010/main" val="0"/>
+              </a:ext>
+            </a:extLst>
+          </a:blip>
+          <a:stretch>
+            <a:fillRect/>
+          </a:stretch>
+        </p:blipFill>
+        <p:spPr>
+          <a:xfrm>
+            <a:off x="830769" y="3404817"/>
+            <a:ext cx="3877055" cy="2907792"/>
+          </a:xfrm>
+          <a:prstGeom prst="rect">
+            <a:avLst/>
+          </a:prstGeom>
+        </p:spPr>
+      </p:pic>
+    </p:spTree>
+    <p:extLst>
+      <p:ext uri="{BB962C8B-B14F-4D97-AF65-F5344CB8AC3E}">
+        <p14:creationId xmlns:p14="http://schemas.microsoft.com/office/powerpoint/2010/main" val="2201325296"/>
       </p:ext>
     </p:extLst>
   </p:cSld>

</xml_diff>